<commit_message>
Ajoute charte IA formation, packs prospection, guides CR Réunion et supports connexes
- Charte d'utilisation responsable de l'IA (livrable formation décideurs)
- Packs prospection manuels Attijari CI, ELTON OIL CI, SIR, SMB (courrier + deck + mini-catalogue)
- Guides utilisateur workflow 128 (CR Réunion international, FR/EN/multilingue)
- Documents de différenciation écosystème technologique TransferAI x NettelecomCI
- Export RAG programme formation juillet 2026 et mises à jour supports pré-clôture bancaire/newsletter webinaire

Co-Authored-By: Claude Sonnet 5 <noreply@anthropic.com>
</commit_message>
<xml_diff>
--- a/outputs/manual-20260705-pre-cloture-bancaire/TransferAI_Presentation_Pre_Cloture_Bancaire_Multi_Banques.pptx
+++ b/outputs/manual-20260705-pre-cloture-bancaire/TransferAI_Presentation_Pre_Cloture_Bancaire_Multi_Banques.pptx
@@ -2,17 +2,18 @@
 <file path=ppt/presentation.xml><?xml version="1.0" encoding="utf-8"?>
 <p:presentation xmlns:p="http://schemas.openxmlformats.org/presentationml/2006/main">
   <p:sldMasterIdLst>
-    <p:sldMasterId xmlns:r="http://schemas.openxmlformats.org/officeDocument/2006/relationships" id="2147483648" r:id="R7e0d6d2e43bc4a63"/>
+    <p:sldMasterId xmlns:r="http://schemas.openxmlformats.org/officeDocument/2006/relationships" id="2147483648" r:id="R827a4bf2ecc24665"/>
   </p:sldMasterIdLst>
   <p:notesMasterIdLst>
-    <p:notesMasterId xmlns:r="http://schemas.openxmlformats.org/officeDocument/2006/relationships" r:id="R4b795f0a073a496b"/>
+    <p:notesMasterId xmlns:r="http://schemas.openxmlformats.org/officeDocument/2006/relationships" r:id="R2f7a9a0f4a344ad6"/>
   </p:notesMasterIdLst>
   <p:sldIdLst>
-    <p:sldId xmlns:r="http://schemas.openxmlformats.org/officeDocument/2006/relationships" id="256" r:id="R4c499b42340e4e6b"/>
-    <p:sldId xmlns:r="http://schemas.openxmlformats.org/officeDocument/2006/relationships" id="257" r:id="Rc9e34aa16be14187"/>
-    <p:sldId xmlns:r="http://schemas.openxmlformats.org/officeDocument/2006/relationships" id="258" r:id="R57c0ef0510ff4c7e"/>
-    <p:sldId xmlns:r="http://schemas.openxmlformats.org/officeDocument/2006/relationships" id="259" r:id="R3a4ea0039e1b46ce"/>
-    <p:sldId xmlns:r="http://schemas.openxmlformats.org/officeDocument/2006/relationships" id="260" r:id="R53020f570e514a22"/>
+    <p:sldId xmlns:r="http://schemas.openxmlformats.org/officeDocument/2006/relationships" id="256" r:id="R6e48d5ce4a1f415a"/>
+    <p:sldId xmlns:r="http://schemas.openxmlformats.org/officeDocument/2006/relationships" id="257" r:id="R89f7a2028df3413a"/>
+    <p:sldId xmlns:r="http://schemas.openxmlformats.org/officeDocument/2006/relationships" id="258" r:id="R16a59178033c4a3c"/>
+    <p:sldId xmlns:r="http://schemas.openxmlformats.org/officeDocument/2006/relationships" id="259" r:id="R43266eb54b2941cd"/>
+    <p:sldId xmlns:r="http://schemas.openxmlformats.org/officeDocument/2006/relationships" id="260" r:id="R83241155ae2e4293"/>
+    <p:sldId xmlns:r="http://schemas.openxmlformats.org/officeDocument/2006/relationships" id="261" r:id="R20286b06b30d453a"/>
   </p:sldIdLst>
   <p:sldSz cx="12192000" cy="6858000"/>
   <p:notesSz cx="6858000" cy="9144000"/>
@@ -831,6 +832,72 @@
 </p:notes>
 </file>
 
+<file path=ppt/notesSlides/notesSlide6.xml><?xml version="1.0" encoding="utf-8"?>
+<p:notes xmlns:p="http://schemas.openxmlformats.org/presentationml/2006/main">
+  <p:cSld>
+    <p:spTree>
+      <p:nvGrpSpPr>
+        <p:cNvPr id="1" name=""/>
+        <p:cNvGrpSpPr/>
+        <p:nvPr/>
+      </p:nvGrpSpPr>
+      <p:grpSpPr>
+        <a:xfrm xmlns:a="http://schemas.openxmlformats.org/drawingml/2006/main"/>
+      </p:grpSpPr>
+      <p:sp>
+        <p:nvSpPr>
+          <p:cNvPr id="2" name="Slide Image Placeholder 1"/>
+          <p:cNvSpPr>
+            <a:spLocks xmlns:a="http://schemas.openxmlformats.org/drawingml/2006/main" noGrp="1"/>
+          </p:cNvSpPr>
+          <p:nvPr>
+            <p:ph type="sldImg" idx="0"/>
+          </p:nvPr>
+        </p:nvSpPr>
+        <p:spPr/>
+      </p:sp>
+      <p:sp>
+        <p:nvSpPr>
+          <p:cNvPr id="3" name="Notes Placeholder 2"/>
+          <p:cNvSpPr>
+            <a:spLocks xmlns:a="http://schemas.openxmlformats.org/drawingml/2006/main" noGrp="1"/>
+          </p:cNvSpPr>
+          <p:nvPr>
+            <p:ph type="body" idx="1"/>
+          </p:nvPr>
+        </p:nvSpPr>
+        <p:spPr/>
+        <p:txBody>
+          <a:bodyPr xmlns:a="http://schemas.openxmlformats.org/drawingml/2006/main"/>
+          <a:lstStyle xmlns:a="http://schemas.openxmlformats.org/drawingml/2006/main"/>
+          <a:p xmlns:a="http://schemas.openxmlformats.org/drawingml/2006/main"/>
+        </p:txBody>
+      </p:sp>
+      <p:sp>
+        <p:nvSpPr>
+          <p:cNvPr id="4" name="Slide Number Placeholder 3"/>
+          <p:cNvSpPr>
+            <a:spLocks xmlns:a="http://schemas.openxmlformats.org/drawingml/2006/main" noGrp="1"/>
+          </p:cNvSpPr>
+          <p:nvPr>
+            <p:ph type="sldNum" idx="5"/>
+          </p:nvPr>
+        </p:nvSpPr>
+        <p:spPr/>
+        <p:txBody>
+          <a:bodyPr xmlns:a="http://schemas.openxmlformats.org/drawingml/2006/main"/>
+          <a:lstStyle xmlns:a="http://schemas.openxmlformats.org/drawingml/2006/main"/>
+          <a:p xmlns:a="http://schemas.openxmlformats.org/drawingml/2006/main"/>
+        </p:txBody>
+      </p:sp>
+    </p:spTree>
+  </p:cSld>
+  <p:clrMapOvr>
+    <a:masterClrMapping xmlns:a="http://schemas.openxmlformats.org/drawingml/2006/main"/>
+  </p:clrMapOvr>
+</p:notes>
+</file>
+
 <file path=ppt/slideLayouts/slideLayout1.xml><?xml version="1.0" encoding="utf-8"?>
 <p:sldLayout xmlns:p="http://schemas.openxmlformats.org/presentationml/2006/main" type="title">
   <p:cSld name="Title Slide">
@@ -869,7 +936,7 @@
   </p:cSld>
   <p:clrMap bg1="lt1" tx1="dk1" bg2="lt2" tx2="dk2" accent1="accent1" accent2="accent2" accent3="accent3" accent4="accent4" accent5="accent5" accent6="accent6" hlink="hlink" folHlink="folHlink"/>
   <p:sldLayoutIdLst>
-    <p:sldLayoutId xmlns:r="http://schemas.openxmlformats.org/officeDocument/2006/relationships" id="2147483649" r:id="Rc132a4e1c51840a8"/>
+    <p:sldLayoutId xmlns:r="http://schemas.openxmlformats.org/officeDocument/2006/relationships" id="2147483649" r:id="R1af4360bc1134b20"/>
   </p:sldLayoutIdLst>
   <p:txStyles>
     <p:titleStyle>
@@ -1510,14 +1577,14 @@
       </p:sp>
       <p:pic>
         <p:nvPicPr>
-          <p:cNvPr id="13" name=""/>
+          <p:cNvPr id="14" name=""/>
           <p:cNvPicPr>
             <a:picLocks xmlns:a="http://schemas.openxmlformats.org/drawingml/2006/main" noChangeAspect="1"/>
           </p:cNvPicPr>
           <p:nvPr/>
         </p:nvPicPr>
         <p:blipFill>
-          <a:blip xmlns:r="http://schemas.openxmlformats.org/officeDocument/2006/relationships" xmlns:a="http://schemas.openxmlformats.org/drawingml/2006/main" r:embed="R9ce758b08ec34d5b"/>
+          <a:blip xmlns:r="http://schemas.openxmlformats.org/officeDocument/2006/relationships" xmlns:a="http://schemas.openxmlformats.org/drawingml/2006/main" r:embed="R67ab9e890c6a413f"/>
           <a:stretch xmlns:a="http://schemas.openxmlformats.org/drawingml/2006/main"/>
         </p:blipFill>
         <p:spPr>
@@ -1995,14 +2062,14 @@
       </p:sp>
       <p:pic>
         <p:nvPicPr>
-          <p:cNvPr id="15" name=""/>
+          <p:cNvPr id="16" name=""/>
           <p:cNvPicPr>
             <a:picLocks xmlns:a="http://schemas.openxmlformats.org/drawingml/2006/main" noChangeAspect="1"/>
           </p:cNvPicPr>
           <p:nvPr/>
         </p:nvPicPr>
         <p:blipFill>
-          <a:blip xmlns:r="http://schemas.openxmlformats.org/officeDocument/2006/relationships" xmlns:a="http://schemas.openxmlformats.org/drawingml/2006/main" r:embed="R8436d357b42240fa"/>
+          <a:blip xmlns:r="http://schemas.openxmlformats.org/officeDocument/2006/relationships" xmlns:a="http://schemas.openxmlformats.org/drawingml/2006/main" r:embed="Rfb7c55995f164f42"/>
           <a:stretch xmlns:a="http://schemas.openxmlformats.org/drawingml/2006/main"/>
         </p:blipFill>
         <p:spPr>
@@ -2824,10 +2891,10 @@
       </p:grpSpPr>
       <p:sp>
         <p:nvSpPr>
-          <p:cNvPr id="1" name="section-Workflow">
-            <a:extLst xmlns:a="http://schemas.openxmlformats.org/drawingml/2006/main">
-              <a:ext uri="{FF2B5EF4-FFF2-40B4-BE49-F238E27FC236}">
-                <a16:creationId xmlns:a16="http://schemas.microsoft.com/office/drawing/2014/main" id="{ADC18810-A9B0-4165-9919-E618AE857868}"/>
+          <p:cNvPr id="1" name="section-Cas d’usage">
+            <a:extLst xmlns:a="http://schemas.openxmlformats.org/drawingml/2006/main">
+              <a:ext uri="{FF2B5EF4-FFF2-40B4-BE49-F238E27FC236}">
+                <a16:creationId xmlns:a16="http://schemas.microsoft.com/office/drawing/2014/main" id="{89A18AFE-898D-46F3-B33B-F3A80E2FB3C1}"/>
               </a:ext>
             </a:extLst>
           </p:cNvPr>
@@ -2879,21 +2946,21 @@
                 <a:ea typeface="Helvetica Neue"/>
                 <a:cs typeface="Helvetica Neue"/>
               </a:rPr>
-              <a:t>Workflow</a:t>
+              <a:t>Conformité</a:t>
             </a:r>
           </a:p>
         </p:txBody>
       </p:sp>
       <p:pic>
         <p:nvPicPr>
-          <p:cNvPr id="20" name=""/>
+          <p:cNvPr id="16" name=""/>
           <p:cNvPicPr>
             <a:picLocks xmlns:a="http://schemas.openxmlformats.org/drawingml/2006/main" noChangeAspect="1"/>
           </p:cNvPicPr>
           <p:nvPr/>
         </p:nvPicPr>
         <p:blipFill>
-          <a:blip xmlns:r="http://schemas.openxmlformats.org/officeDocument/2006/relationships" xmlns:a="http://schemas.openxmlformats.org/drawingml/2006/main" r:embed="R7384a74b3d154949"/>
+          <a:blip xmlns:r="http://schemas.openxmlformats.org/officeDocument/2006/relationships" xmlns:a="http://schemas.openxmlformats.org/drawingml/2006/main" r:embed="R2873c2e9e51446ed"/>
           <a:stretch xmlns:a="http://schemas.openxmlformats.org/drawingml/2006/main"/>
         </p:blipFill>
         <p:spPr>
@@ -2908,10 +2975,10 @@
       </p:pic>
       <p:sp>
         <p:nvSpPr>
-          <p:cNvPr id="3" name="workflow-title">
-            <a:extLst xmlns:a="http://schemas.openxmlformats.org/drawingml/2006/main">
-              <a:ext uri="{FF2B5EF4-FFF2-40B4-BE49-F238E27FC236}">
-                <a16:creationId xmlns:a16="http://schemas.microsoft.com/office/drawing/2014/main" id="{A106B2F9-8159-4744-A9DC-41956514CDE3}"/>
+          <p:cNvPr id="3" name="usecase-title">
+            <a:extLst xmlns:a="http://schemas.openxmlformats.org/drawingml/2006/main">
+              <a:ext uri="{FF2B5EF4-FFF2-40B4-BE49-F238E27FC236}">
+                <a16:creationId xmlns:a16="http://schemas.microsoft.com/office/drawing/2014/main" id="{00AA59E2-715E-4DA9-B33F-22B9A8B6DC4D}"/>
               </a:ext>
             </a:extLst>
           </p:cNvPr>
@@ -2923,7 +2990,7 @@
         <p:spPr>
           <a:xfrm xmlns:a="http://schemas.openxmlformats.org/drawingml/2006/main">
             <a:off x="400050" y="342900"/>
-            <a:ext cx="10572750" cy="666750"/>
+            <a:ext cx="10668000" cy="666750"/>
           </a:xfrm>
           <a:prstGeom xmlns:a="http://schemas.openxmlformats.org/drawingml/2006/main" prst="rect">
             <a:avLst/>
@@ -2936,13 +3003,13 @@
         </p:spPr>
         <p:txBody>
           <a:bodyPr xmlns:a="http://schemas.openxmlformats.org/drawingml/2006/main" wrap="square" lIns="0" tIns="0" rIns="0" bIns="0" anchor="t">
-            <a:normAutofit fontScale="96832"/>
+            <a:normAutofit fontScale="100000"/>
           </a:bodyPr>
           <a:lstStyle xmlns:a="http://schemas.openxmlformats.org/drawingml/2006/main"/>
           <a:p xmlns:a="http://schemas.openxmlformats.org/drawingml/2006/main">
             <a:pPr algn="l">
               <a:lnSpc>
-                <a:spcPct val="108000"/>
+                <a:spcPct val="100000"/>
               </a:lnSpc>
               <a:buNone/>
               <a:defRPr sz="2925" b="0">
@@ -2963,29 +3030,29 @@
                 <a:ea typeface="Helvetica Neue"/>
                 <a:cs typeface="Helvetica Neue"/>
               </a:rPr>
-              <a:t>Le workflow reste simple à expliquer et crédible en démonstration</a:t>
-            </a:r>
-          </a:p>
-        </p:txBody>
-      </p:sp>
-      <p:sp>
-        <p:nvSpPr>
-          <p:cNvPr id="4" name="workflow-intro">
-            <a:extLst xmlns:a="http://schemas.openxmlformats.org/drawingml/2006/main">
-              <a:ext uri="{FF2B5EF4-FFF2-40B4-BE49-F238E27FC236}">
-                <a16:creationId xmlns:a16="http://schemas.microsoft.com/office/drawing/2014/main" id="{D69BB6D7-1801-4C0B-AD55-EB5074D410E1}"/>
-              </a:ext>
-            </a:extLst>
-          </p:cNvPr>
-          <p:cNvSpPr>
-            <a:spLocks xmlns:a="http://schemas.openxmlformats.org/drawingml/2006/main" noGrp="1"/>
-          </p:cNvSpPr>
-          <p:nvPr/>
-        </p:nvSpPr>
-        <p:spPr>
-          <a:xfrm xmlns:a="http://schemas.openxmlformats.org/drawingml/2006/main">
-            <a:off x="400050" y="1123950"/>
-            <a:ext cx="10287000" cy="419100"/>
+              <a:t>Confidentialité bancaire : un cas d’usage maîtrisé</a:t>
+            </a:r>
+          </a:p>
+        </p:txBody>
+      </p:sp>
+      <p:sp>
+        <p:nvSpPr>
+          <p:cNvPr id="4" name="usecase-intro">
+            <a:extLst xmlns:a="http://schemas.openxmlformats.org/drawingml/2006/main">
+              <a:ext uri="{FF2B5EF4-FFF2-40B4-BE49-F238E27FC236}">
+                <a16:creationId xmlns:a16="http://schemas.microsoft.com/office/drawing/2014/main" id="{68183CD0-2E2C-4FBE-A02C-00D990E7B4DA}"/>
+              </a:ext>
+            </a:extLst>
+          </p:cNvPr>
+          <p:cNvSpPr>
+            <a:spLocks xmlns:a="http://schemas.openxmlformats.org/drawingml/2006/main" noGrp="1"/>
+          </p:cNvSpPr>
+          <p:nvPr/>
+        </p:nvSpPr>
+        <p:spPr>
+          <a:xfrm xmlns:a="http://schemas.openxmlformats.org/drawingml/2006/main">
+            <a:off x="400050" y="1200150"/>
+            <a:ext cx="11049000" cy="1123950"/>
           </a:xfrm>
           <a:prstGeom xmlns:a="http://schemas.openxmlformats.org/drawingml/2006/main" prst="rect">
             <a:avLst/>
@@ -2998,56 +3065,56 @@
         </p:spPr>
         <p:txBody>
           <a:bodyPr xmlns:a="http://schemas.openxmlformats.org/drawingml/2006/main" wrap="square" lIns="0" tIns="0" rIns="0" bIns="0" anchor="t">
-            <a:normAutofit fontScale="94336"/>
+            <a:normAutofit fontScale="100000"/>
           </a:bodyPr>
           <a:lstStyle xmlns:a="http://schemas.openxmlformats.org/drawingml/2006/main"/>
           <a:p xmlns:a="http://schemas.openxmlformats.org/drawingml/2006/main">
             <a:pPr algn="l">
               <a:lnSpc>
-                <a:spcPct val="108000"/>
-              </a:lnSpc>
-              <a:buNone/>
-              <a:defRPr sz="1575" b="0">
-                <a:solidFill>
-                  <a:srgbClr val="222222"/>
-                </a:solidFill>
-                <a:latin typeface="Helvetica Neue"/>
-                <a:ea typeface="Helvetica Neue"/>
-                <a:cs typeface="Helvetica Neue"/>
-              </a:defRPr>
-            </a:pPr>
-            <a:r>
-              <a:rPr sz="1575" b="0">
-                <a:solidFill>
-                  <a:srgbClr val="222222"/>
-                </a:solidFill>
-                <a:latin typeface="Helvetica Neue"/>
-                <a:ea typeface="Helvetica Neue"/>
-                <a:cs typeface="Helvetica Neue"/>
-              </a:rPr>
-              <a:t>Le scénario présenté peut rester très opérationnel : dépôt du fichier, contrôles, synthèse IA, puis validation avant diffusion.</a:t>
-            </a:r>
-          </a:p>
-        </p:txBody>
-      </p:sp>
-      <p:sp>
-        <p:nvSpPr>
-          <p:cNvPr id="5" name="workflow-panel-42">
-            <a:extLst xmlns:a="http://schemas.openxmlformats.org/drawingml/2006/main">
-              <a:ext uri="{FF2B5EF4-FFF2-40B4-BE49-F238E27FC236}">
-                <a16:creationId xmlns:a16="http://schemas.microsoft.com/office/drawing/2014/main" id="{8D665570-C736-4FC8-AA00-EC1FEC85A9F4}"/>
-              </a:ext>
-            </a:extLst>
-          </p:cNvPr>
-          <p:cNvSpPr>
-            <a:spLocks xmlns:a="http://schemas.openxmlformats.org/drawingml/2006/main" noGrp="1"/>
-          </p:cNvSpPr>
-          <p:nvPr/>
-        </p:nvSpPr>
-        <p:spPr>
-          <a:xfrm xmlns:a="http://schemas.openxmlformats.org/drawingml/2006/main">
-            <a:off x="400050" y="1771650"/>
-            <a:ext cx="2590800" cy="3105150"/>
+                <a:spcPct val="120000"/>
+              </a:lnSpc>
+              <a:buNone/>
+              <a:defRPr sz="1500" b="0">
+                <a:solidFill>
+                  <a:srgbClr val="222222"/>
+                </a:solidFill>
+                <a:latin typeface="Helvetica Neue"/>
+                <a:ea typeface="Helvetica Neue"/>
+                <a:cs typeface="Helvetica Neue"/>
+              </a:defRPr>
+            </a:pPr>
+            <a:r>
+              <a:rPr sz="1500" b="0">
+                <a:solidFill>
+                  <a:srgbClr val="222222"/>
+                </a:solidFill>
+                <a:latin typeface="Helvetica Neue"/>
+                <a:ea typeface="Helvetica Neue"/>
+                <a:cs typeface="Helvetica Neue"/>
+              </a:rPr>
+              <a:t>Avant l’appel IA, les données sensibles sont pseudonymisées afin de limiter l’exposition des informations à caractère personnel. Le modèle ne reçoit que les éléments utiles à l’analyse des écarts, tandis que les références détaillées restent sous contrôle interne et sous validation humaine.</a:t>
+            </a:r>
+          </a:p>
+        </p:txBody>
+      </p:sp>
+      <p:sp>
+        <p:nvSpPr>
+          <p:cNvPr id="5" name="automation-panel">
+            <a:extLst xmlns:a="http://schemas.openxmlformats.org/drawingml/2006/main">
+              <a:ext uri="{FF2B5EF4-FFF2-40B4-BE49-F238E27FC236}">
+                <a16:creationId xmlns:a16="http://schemas.microsoft.com/office/drawing/2014/main" id="{48D7E23E-1BB6-441D-A685-5C4B266A7728}"/>
+              </a:ext>
+            </a:extLst>
+          </p:cNvPr>
+          <p:cNvSpPr>
+            <a:spLocks xmlns:a="http://schemas.openxmlformats.org/drawingml/2006/main" noGrp="1"/>
+          </p:cNvSpPr>
+          <p:nvPr/>
+        </p:nvSpPr>
+        <p:spPr>
+          <a:xfrm xmlns:a="http://schemas.openxmlformats.org/drawingml/2006/main">
+            <a:off x="400050" y="2724150"/>
+            <a:ext cx="5534025" cy="2724150"/>
           </a:xfrm>
           <a:prstGeom xmlns:a="http://schemas.openxmlformats.org/drawingml/2006/main" prst="rect">
             <a:avLst/>
@@ -3063,22 +3130,22 @@
       </p:sp>
       <p:sp>
         <p:nvSpPr>
-          <p:cNvPr id="6" name="workflow-step-42">
-            <a:extLst xmlns:a="http://schemas.openxmlformats.org/drawingml/2006/main">
-              <a:ext uri="{FF2B5EF4-FFF2-40B4-BE49-F238E27FC236}">
-                <a16:creationId xmlns:a16="http://schemas.microsoft.com/office/drawing/2014/main" id="{0D88EA9F-1AB6-477A-84FE-BD1DDD67C9FD}"/>
-              </a:ext>
-            </a:extLst>
-          </p:cNvPr>
-          <p:cNvSpPr>
-            <a:spLocks xmlns:a="http://schemas.openxmlformats.org/drawingml/2006/main" noGrp="1"/>
-          </p:cNvSpPr>
-          <p:nvPr/>
-        </p:nvSpPr>
-        <p:spPr>
-          <a:xfrm xmlns:a="http://schemas.openxmlformats.org/drawingml/2006/main">
-            <a:off x="628650" y="2057400"/>
-            <a:ext cx="2095500" cy="571500"/>
+          <p:cNvPr id="6" name="automation-title">
+            <a:extLst xmlns:a="http://schemas.openxmlformats.org/drawingml/2006/main">
+              <a:ext uri="{FF2B5EF4-FFF2-40B4-BE49-F238E27FC236}">
+                <a16:creationId xmlns:a16="http://schemas.microsoft.com/office/drawing/2014/main" id="{44DED0F2-56CE-47A6-BB67-074AA6ACC05E}"/>
+              </a:ext>
+            </a:extLst>
+          </p:cNvPr>
+          <p:cNvSpPr>
+            <a:spLocks xmlns:a="http://schemas.openxmlformats.org/drawingml/2006/main" noGrp="1"/>
+          </p:cNvSpPr>
+          <p:nvPr/>
+        </p:nvSpPr>
+        <p:spPr>
+          <a:xfrm xmlns:a="http://schemas.openxmlformats.org/drawingml/2006/main">
+            <a:off x="666750" y="3000375"/>
+            <a:ext cx="4762500" cy="323850"/>
           </a:xfrm>
           <a:prstGeom xmlns:a="http://schemas.openxmlformats.org/drawingml/2006/main" prst="rect">
             <a:avLst/>
@@ -3091,13 +3158,13 @@
         </p:spPr>
         <p:txBody>
           <a:bodyPr xmlns:a="http://schemas.openxmlformats.org/drawingml/2006/main" wrap="square" lIns="0" tIns="0" rIns="0" bIns="0" anchor="t">
-            <a:normAutofit fontScale="90777"/>
+            <a:normAutofit fontScale="97165"/>
           </a:bodyPr>
           <a:lstStyle xmlns:a="http://schemas.openxmlformats.org/drawingml/2006/main"/>
           <a:p xmlns:a="http://schemas.openxmlformats.org/drawingml/2006/main">
             <a:pPr algn="l">
               <a:lnSpc>
-                <a:spcPct val="102000"/>
+                <a:spcPct val="108000"/>
               </a:lnSpc>
               <a:buNone/>
               <a:defRPr sz="2025" b="0">
@@ -3118,29 +3185,29 @@
                 <a:ea typeface="Helvetica Neue"/>
                 <a:cs typeface="Helvetica Neue"/>
               </a:rPr>
-              <a:t>1. Dépôt des données</a:t>
-            </a:r>
-          </a:p>
-        </p:txBody>
-      </p:sp>
-      <p:sp>
-        <p:nvSpPr>
-          <p:cNvPr id="7" name="workflow-body-42">
-            <a:extLst xmlns:a="http://schemas.openxmlformats.org/drawingml/2006/main">
-              <a:ext uri="{FF2B5EF4-FFF2-40B4-BE49-F238E27FC236}">
-                <a16:creationId xmlns:a16="http://schemas.microsoft.com/office/drawing/2014/main" id="{2488F420-3F66-4ED8-99B8-B6657335411C}"/>
-              </a:ext>
-            </a:extLst>
-          </p:cNvPr>
-          <p:cNvSpPr>
-            <a:spLocks xmlns:a="http://schemas.openxmlformats.org/drawingml/2006/main" noGrp="1"/>
-          </p:cNvSpPr>
-          <p:nvPr/>
-        </p:nvSpPr>
-        <p:spPr>
-          <a:xfrm xmlns:a="http://schemas.openxmlformats.org/drawingml/2006/main">
-            <a:off x="628650" y="3124200"/>
-            <a:ext cx="2095500" cy="1257300"/>
+              <a:t>Ce que fait la protection</a:t>
+            </a:r>
+          </a:p>
+        </p:txBody>
+      </p:sp>
+      <p:sp>
+        <p:nvSpPr>
+          <p:cNvPr id="7" name="automation-bullets">
+            <a:extLst xmlns:a="http://schemas.openxmlformats.org/drawingml/2006/main">
+              <a:ext uri="{FF2B5EF4-FFF2-40B4-BE49-F238E27FC236}">
+                <a16:creationId xmlns:a16="http://schemas.microsoft.com/office/drawing/2014/main" id="{B7A9203D-7426-49FC-A52F-2D2C14FCAB44}"/>
+              </a:ext>
+            </a:extLst>
+          </p:cNvPr>
+          <p:cNvSpPr>
+            <a:spLocks xmlns:a="http://schemas.openxmlformats.org/drawingml/2006/main" noGrp="1"/>
+          </p:cNvSpPr>
+          <p:nvPr/>
+        </p:nvSpPr>
+        <p:spPr>
+          <a:xfrm xmlns:a="http://schemas.openxmlformats.org/drawingml/2006/main">
+            <a:off x="666750" y="3476625"/>
+            <a:ext cx="4933950" cy="1695450"/>
           </a:xfrm>
           <a:prstGeom xmlns:a="http://schemas.openxmlformats.org/drawingml/2006/main" prst="rect">
             <a:avLst/>
@@ -3157,52 +3224,160 @@
           </a:bodyPr>
           <a:lstStyle xmlns:a="http://schemas.openxmlformats.org/drawingml/2006/main"/>
           <a:p xmlns:a="http://schemas.openxmlformats.org/drawingml/2006/main">
-            <a:pPr algn="l">
-              <a:lnSpc>
-                <a:spcPct val="116000"/>
-              </a:lnSpc>
-              <a:buNone/>
-              <a:defRPr sz="1350" b="0">
-                <a:solidFill>
-                  <a:srgbClr val="222222"/>
-                </a:solidFill>
-                <a:latin typeface="Helvetica Neue"/>
-                <a:ea typeface="Helvetica Neue"/>
-                <a:cs typeface="Helvetica Neue"/>
-              </a:defRPr>
-            </a:pPr>
-            <a:r>
-              <a:rPr sz="1350" b="0">
-                <a:solidFill>
-                  <a:srgbClr val="222222"/>
-                </a:solidFill>
-                <a:latin typeface="Helvetica Neue"/>
-                <a:ea typeface="Helvetica Neue"/>
-                <a:cs typeface="Helvetica Neue"/>
-              </a:rPr>
-              <a:t>Un export comptable, un fichier Excel ou un CSV de pré-clôture est transmis dans le workflow.</a:t>
-            </a:r>
-          </a:p>
-        </p:txBody>
-      </p:sp>
-      <p:sp>
-        <p:nvSpPr>
-          <p:cNvPr id="8" name="workflow-panel-350">
-            <a:extLst xmlns:a="http://schemas.openxmlformats.org/drawingml/2006/main">
-              <a:ext uri="{FF2B5EF4-FFF2-40B4-BE49-F238E27FC236}">
-                <a16:creationId xmlns:a16="http://schemas.microsoft.com/office/drawing/2014/main" id="{1801B570-8C2E-4106-B281-C449138A8292}"/>
-              </a:ext>
-            </a:extLst>
-          </p:cNvPr>
-          <p:cNvSpPr>
-            <a:spLocks xmlns:a="http://schemas.openxmlformats.org/drawingml/2006/main" noGrp="1"/>
-          </p:cNvSpPr>
-          <p:nvPr/>
-        </p:nvSpPr>
-        <p:spPr>
-          <a:xfrm xmlns:a="http://schemas.openxmlformats.org/drawingml/2006/main">
-            <a:off x="3333750" y="1771650"/>
-            <a:ext cx="2590800" cy="3105150"/>
+            <a:pPr marL="24" indent="-14" algn="l">
+              <a:lnSpc>
+                <a:spcPct val="115000"/>
+              </a:lnSpc>
+              <a:buNone/>
+              <a:defRPr sz="1275" b="0">
+                <a:solidFill>
+                  <a:srgbClr val="222222"/>
+                </a:solidFill>
+                <a:latin typeface="Helvetica Neue"/>
+                <a:ea typeface="Helvetica Neue"/>
+                <a:cs typeface="Helvetica Neue"/>
+              </a:defRPr>
+            </a:pPr>
+            <a:r>
+              <a:rPr sz="1275" b="0">
+                <a:solidFill>
+                  <a:srgbClr val="222222"/>
+                </a:solidFill>
+                <a:latin typeface="Helvetica Neue"/>
+                <a:ea typeface="Helvetica Neue"/>
+                <a:cs typeface="Helvetica Neue"/>
+              </a:rPr>
+              <a:t>Généricisation du nom de la banque pour l’étape IA.</a:t>
+            </a:r>
+          </a:p>
+          <a:p xmlns:a="http://schemas.openxmlformats.org/drawingml/2006/main">
+            <a:pPr marL="24" indent="-14" algn="l">
+              <a:lnSpc>
+                <a:spcPct val="115000"/>
+              </a:lnSpc>
+              <a:buNone/>
+              <a:defRPr sz="1275" b="0">
+                <a:solidFill>
+                  <a:srgbClr val="222222"/>
+                </a:solidFill>
+                <a:latin typeface="Helvetica Neue"/>
+                <a:ea typeface="Helvetica Neue"/>
+                <a:cs typeface="Helvetica Neue"/>
+              </a:defRPr>
+            </a:pPr>
+            <a:r>
+              <a:rPr sz="1275" b="0">
+                <a:solidFill>
+                  <a:srgbClr val="222222"/>
+                </a:solidFill>
+                <a:latin typeface="Helvetica Neue"/>
+                <a:ea typeface="Helvetica Neue"/>
+                <a:cs typeface="Helvetica Neue"/>
+              </a:rPr>
+              <a:t>Masquage des e-mails, téléphones et identifiants longs.</a:t>
+            </a:r>
+          </a:p>
+          <a:p xmlns:a="http://schemas.openxmlformats.org/drawingml/2006/main">
+            <a:pPr marL="24" indent="-14" algn="l">
+              <a:lnSpc>
+                <a:spcPct val="115000"/>
+              </a:lnSpc>
+              <a:buNone/>
+              <a:defRPr sz="1275" b="0">
+                <a:solidFill>
+                  <a:srgbClr val="222222"/>
+                </a:solidFill>
+                <a:latin typeface="Helvetica Neue"/>
+                <a:ea typeface="Helvetica Neue"/>
+                <a:cs typeface="Helvetica Neue"/>
+              </a:defRPr>
+            </a:pPr>
+            <a:r>
+              <a:rPr sz="1275" b="0">
+                <a:solidFill>
+                  <a:srgbClr val="222222"/>
+                </a:solidFill>
+                <a:latin typeface="Helvetica Neue"/>
+                <a:ea typeface="Helvetica Neue"/>
+                <a:cs typeface="Helvetica Neue"/>
+              </a:rPr>
+              <a:t>Troncature des numéros de compte et nettoyage des libellés libres.</a:t>
+            </a:r>
+          </a:p>
+          <a:p xmlns:a="http://schemas.openxmlformats.org/drawingml/2006/main">
+            <a:pPr marL="24" indent="-14" algn="l">
+              <a:lnSpc>
+                <a:spcPct val="115000"/>
+              </a:lnSpc>
+              <a:buNone/>
+              <a:defRPr sz="1275" b="0">
+                <a:solidFill>
+                  <a:srgbClr val="222222"/>
+                </a:solidFill>
+                <a:latin typeface="Helvetica Neue"/>
+                <a:ea typeface="Helvetica Neue"/>
+                <a:cs typeface="Helvetica Neue"/>
+              </a:defRPr>
+            </a:pPr>
+            <a:r>
+              <a:rPr sz="1275" b="0">
+                <a:solidFill>
+                  <a:srgbClr val="222222"/>
+                </a:solidFill>
+                <a:latin typeface="Helvetica Neue"/>
+                <a:ea typeface="Helvetica Neue"/>
+                <a:cs typeface="Helvetica Neue"/>
+              </a:rPr>
+              <a:t>Transmission au modèle des seuls KPI et anomalies pseudonymisés.</a:t>
+            </a:r>
+          </a:p>
+          <a:p xmlns:a="http://schemas.openxmlformats.org/drawingml/2006/main">
+            <a:pPr marL="24" indent="-14" algn="l">
+              <a:lnSpc>
+                <a:spcPct val="115000"/>
+              </a:lnSpc>
+              <a:buNone/>
+              <a:defRPr sz="1275" b="0">
+                <a:solidFill>
+                  <a:srgbClr val="222222"/>
+                </a:solidFill>
+                <a:latin typeface="Helvetica Neue"/>
+                <a:ea typeface="Helvetica Neue"/>
+                <a:cs typeface="Helvetica Neue"/>
+              </a:defRPr>
+            </a:pPr>
+            <a:r>
+              <a:rPr sz="1275" b="0">
+                <a:solidFill>
+                  <a:srgbClr val="222222"/>
+                </a:solidFill>
+                <a:latin typeface="Helvetica Neue"/>
+                <a:ea typeface="Helvetica Neue"/>
+                <a:cs typeface="Helvetica Neue"/>
+              </a:rPr>
+              <a:t>Conservation des données détaillées dans le flux interne n8n.</a:t>
+            </a:r>
+          </a:p>
+        </p:txBody>
+      </p:sp>
+      <p:sp>
+        <p:nvSpPr>
+          <p:cNvPr id="8" name="manager-panel">
+            <a:extLst xmlns:a="http://schemas.openxmlformats.org/drawingml/2006/main">
+              <a:ext uri="{FF2B5EF4-FFF2-40B4-BE49-F238E27FC236}">
+                <a16:creationId xmlns:a16="http://schemas.microsoft.com/office/drawing/2014/main" id="{1E7F4F50-645D-4E63-8BE4-F5CAF29FA44E}"/>
+              </a:ext>
+            </a:extLst>
+          </p:cNvPr>
+          <p:cNvSpPr>
+            <a:spLocks xmlns:a="http://schemas.openxmlformats.org/drawingml/2006/main" noGrp="1"/>
+          </p:cNvSpPr>
+          <p:nvPr/>
+        </p:nvSpPr>
+        <p:spPr>
+          <a:xfrm xmlns:a="http://schemas.openxmlformats.org/drawingml/2006/main">
+            <a:off x="6257925" y="2724150"/>
+            <a:ext cx="5534025" cy="2724150"/>
           </a:xfrm>
           <a:prstGeom xmlns:a="http://schemas.openxmlformats.org/drawingml/2006/main" prst="rect">
             <a:avLst/>
@@ -3218,22 +3393,22 @@
       </p:sp>
       <p:sp>
         <p:nvSpPr>
-          <p:cNvPr id="9" name="workflow-step-350">
-            <a:extLst xmlns:a="http://schemas.openxmlformats.org/drawingml/2006/main">
-              <a:ext uri="{FF2B5EF4-FFF2-40B4-BE49-F238E27FC236}">
-                <a16:creationId xmlns:a16="http://schemas.microsoft.com/office/drawing/2014/main" id="{D279FE60-4D25-4681-8948-DDDCACA81305}"/>
-              </a:ext>
-            </a:extLst>
-          </p:cNvPr>
-          <p:cNvSpPr>
-            <a:spLocks xmlns:a="http://schemas.openxmlformats.org/drawingml/2006/main" noGrp="1"/>
-          </p:cNvSpPr>
-          <p:nvPr/>
-        </p:nvSpPr>
-        <p:spPr>
-          <a:xfrm xmlns:a="http://schemas.openxmlformats.org/drawingml/2006/main">
-            <a:off x="3562350" y="2057400"/>
-            <a:ext cx="2095500" cy="571500"/>
+          <p:cNvPr id="9" name="manager-title">
+            <a:extLst xmlns:a="http://schemas.openxmlformats.org/drawingml/2006/main">
+              <a:ext uri="{FF2B5EF4-FFF2-40B4-BE49-F238E27FC236}">
+                <a16:creationId xmlns:a16="http://schemas.microsoft.com/office/drawing/2014/main" id="{639FDEE1-9EBB-4A3C-93EA-AC8AAC42A029}"/>
+              </a:ext>
+            </a:extLst>
+          </p:cNvPr>
+          <p:cNvSpPr>
+            <a:spLocks xmlns:a="http://schemas.openxmlformats.org/drawingml/2006/main" noGrp="1"/>
+          </p:cNvSpPr>
+          <p:nvPr/>
+        </p:nvSpPr>
+        <p:spPr>
+          <a:xfrm xmlns:a="http://schemas.openxmlformats.org/drawingml/2006/main">
+            <a:off x="6562725" y="3000375"/>
+            <a:ext cx="4762500" cy="323850"/>
           </a:xfrm>
           <a:prstGeom xmlns:a="http://schemas.openxmlformats.org/drawingml/2006/main" prst="rect">
             <a:avLst/>
@@ -3246,13 +3421,13 @@
         </p:spPr>
         <p:txBody>
           <a:bodyPr xmlns:a="http://schemas.openxmlformats.org/drawingml/2006/main" wrap="square" lIns="0" tIns="0" rIns="0" bIns="0" anchor="t">
-            <a:normAutofit fontScale="97765"/>
+            <a:normAutofit fontScale="97165"/>
           </a:bodyPr>
           <a:lstStyle xmlns:a="http://schemas.openxmlformats.org/drawingml/2006/main"/>
           <a:p xmlns:a="http://schemas.openxmlformats.org/drawingml/2006/main">
             <a:pPr algn="l">
               <a:lnSpc>
-                <a:spcPct val="102000"/>
+                <a:spcPct val="108000"/>
               </a:lnSpc>
               <a:buNone/>
               <a:defRPr sz="2025" b="0">
@@ -3273,29 +3448,29 @@
                 <a:ea typeface="Helvetica Neue"/>
                 <a:cs typeface="Helvetica Neue"/>
               </a:rPr>
-              <a:t>2. Contrôles ciblés</a:t>
-            </a:r>
-          </a:p>
-        </p:txBody>
-      </p:sp>
-      <p:sp>
-        <p:nvSpPr>
-          <p:cNvPr id="10" name="workflow-body-350">
-            <a:extLst xmlns:a="http://schemas.openxmlformats.org/drawingml/2006/main">
-              <a:ext uri="{FF2B5EF4-FFF2-40B4-BE49-F238E27FC236}">
-                <a16:creationId xmlns:a16="http://schemas.microsoft.com/office/drawing/2014/main" id="{39ECA206-93B2-4C17-A422-C52ACAD8DC4F}"/>
-              </a:ext>
-            </a:extLst>
-          </p:cNvPr>
-          <p:cNvSpPr>
-            <a:spLocks xmlns:a="http://schemas.openxmlformats.org/drawingml/2006/main" noGrp="1"/>
-          </p:cNvSpPr>
-          <p:nvPr/>
-        </p:nvSpPr>
-        <p:spPr>
-          <a:xfrm xmlns:a="http://schemas.openxmlformats.org/drawingml/2006/main">
-            <a:off x="3562350" y="3124200"/>
-            <a:ext cx="2095500" cy="1257300"/>
+              <a:t>Ce que cela garantit</a:t>
+            </a:r>
+          </a:p>
+        </p:txBody>
+      </p:sp>
+      <p:sp>
+        <p:nvSpPr>
+          <p:cNvPr id="10" name="manager-bullets">
+            <a:extLst xmlns:a="http://schemas.openxmlformats.org/drawingml/2006/main">
+              <a:ext uri="{FF2B5EF4-FFF2-40B4-BE49-F238E27FC236}">
+                <a16:creationId xmlns:a16="http://schemas.microsoft.com/office/drawing/2014/main" id="{0622E13E-D1A7-4E3E-B067-3CFBE623D594}"/>
+              </a:ext>
+            </a:extLst>
+          </p:cNvPr>
+          <p:cNvSpPr>
+            <a:spLocks xmlns:a="http://schemas.openxmlformats.org/drawingml/2006/main" noGrp="1"/>
+          </p:cNvSpPr>
+          <p:nvPr/>
+        </p:nvSpPr>
+        <p:spPr>
+          <a:xfrm xmlns:a="http://schemas.openxmlformats.org/drawingml/2006/main">
+            <a:off x="6562725" y="3476625"/>
+            <a:ext cx="4933950" cy="1695450"/>
           </a:xfrm>
           <a:prstGeom xmlns:a="http://schemas.openxmlformats.org/drawingml/2006/main" prst="rect">
             <a:avLst/>
@@ -3312,58 +3487,139 @@
           </a:bodyPr>
           <a:lstStyle xmlns:a="http://schemas.openxmlformats.org/drawingml/2006/main"/>
           <a:p xmlns:a="http://schemas.openxmlformats.org/drawingml/2006/main">
-            <a:pPr algn="l">
-              <a:lnSpc>
-                <a:spcPct val="116000"/>
-              </a:lnSpc>
-              <a:buNone/>
-              <a:defRPr sz="1350" b="0">
-                <a:solidFill>
-                  <a:srgbClr val="222222"/>
-                </a:solidFill>
-                <a:latin typeface="Helvetica Neue"/>
-                <a:ea typeface="Helvetica Neue"/>
-                <a:cs typeface="Helvetica Neue"/>
-              </a:defRPr>
-            </a:pPr>
-            <a:r>
-              <a:rPr sz="1350" b="0">
-                <a:solidFill>
-                  <a:srgbClr val="222222"/>
-                </a:solidFill>
-                <a:latin typeface="Helvetica Neue"/>
-                <a:ea typeface="Helvetica Neue"/>
-                <a:cs typeface="Helvetica Neue"/>
-              </a:rPr>
-              <a:t>Les règles détectent les écarts, les seuils dépassés, les incohérences et les justificatifs manquants.</a:t>
-            </a:r>
-          </a:p>
-        </p:txBody>
-      </p:sp>
-      <p:sp>
-        <p:nvSpPr>
-          <p:cNvPr id="11" name="workflow-panel-658">
-            <a:extLst xmlns:a="http://schemas.openxmlformats.org/drawingml/2006/main">
-              <a:ext uri="{FF2B5EF4-FFF2-40B4-BE49-F238E27FC236}">
-                <a16:creationId xmlns:a16="http://schemas.microsoft.com/office/drawing/2014/main" id="{9532FA9B-5379-47EE-A4D5-9558AB13A05F}"/>
-              </a:ext>
-            </a:extLst>
-          </p:cNvPr>
-          <p:cNvSpPr>
-            <a:spLocks xmlns:a="http://schemas.openxmlformats.org/drawingml/2006/main" noGrp="1"/>
-          </p:cNvSpPr>
-          <p:nvPr/>
-        </p:nvSpPr>
-        <p:spPr>
-          <a:xfrm xmlns:a="http://schemas.openxmlformats.org/drawingml/2006/main">
-            <a:off x="6267450" y="1771650"/>
-            <a:ext cx="2590800" cy="3105150"/>
+            <a:pPr marL="24" indent="-14" algn="l">
+              <a:lnSpc>
+                <a:spcPct val="115000"/>
+              </a:lnSpc>
+              <a:buNone/>
+              <a:defRPr sz="1275" b="0">
+                <a:solidFill>
+                  <a:srgbClr val="222222"/>
+                </a:solidFill>
+                <a:latin typeface="Helvetica Neue"/>
+                <a:ea typeface="Helvetica Neue"/>
+                <a:cs typeface="Helvetica Neue"/>
+              </a:defRPr>
+            </a:pPr>
+            <a:r>
+              <a:rPr sz="1275" b="0">
+                <a:solidFill>
+                  <a:srgbClr val="222222"/>
+                </a:solidFill>
+                <a:latin typeface="Helvetica Neue"/>
+                <a:ea typeface="Helvetica Neue"/>
+                <a:cs typeface="Helvetica Neue"/>
+              </a:rPr>
+              <a:t>Réduction du risque d’exposition des données sensibles.</a:t>
+            </a:r>
+          </a:p>
+          <a:p xmlns:a="http://schemas.openxmlformats.org/drawingml/2006/main">
+            <a:pPr marL="24" indent="-14" algn="l">
+              <a:lnSpc>
+                <a:spcPct val="115000"/>
+              </a:lnSpc>
+              <a:buNone/>
+              <a:defRPr sz="1275" b="0">
+                <a:solidFill>
+                  <a:srgbClr val="222222"/>
+                </a:solidFill>
+                <a:latin typeface="Helvetica Neue"/>
+                <a:ea typeface="Helvetica Neue"/>
+                <a:cs typeface="Helvetica Neue"/>
+              </a:defRPr>
+            </a:pPr>
+            <a:r>
+              <a:rPr sz="1275" b="0">
+                <a:solidFill>
+                  <a:srgbClr val="222222"/>
+                </a:solidFill>
+                <a:latin typeface="Helvetica Neue"/>
+                <a:ea typeface="Helvetica Neue"/>
+                <a:cs typeface="Helvetica Neue"/>
+              </a:rPr>
+              <a:t>Commentaire IA produit sans dépendre d’identités réelles.</a:t>
+            </a:r>
+          </a:p>
+          <a:p xmlns:a="http://schemas.openxmlformats.org/drawingml/2006/main">
+            <a:pPr marL="24" indent="-14" algn="l">
+              <a:lnSpc>
+                <a:spcPct val="115000"/>
+              </a:lnSpc>
+              <a:buNone/>
+              <a:defRPr sz="1275" b="0">
+                <a:solidFill>
+                  <a:srgbClr val="222222"/>
+                </a:solidFill>
+                <a:latin typeface="Helvetica Neue"/>
+                <a:ea typeface="Helvetica Neue"/>
+                <a:cs typeface="Helvetica Neue"/>
+              </a:defRPr>
+            </a:pPr>
+            <a:r>
+              <a:rPr sz="1275" b="0">
+                <a:solidFill>
+                  <a:srgbClr val="222222"/>
+                </a:solidFill>
+                <a:latin typeface="Helvetica Neue"/>
+                <a:ea typeface="Helvetica Neue"/>
+                <a:cs typeface="Helvetica Neue"/>
+              </a:rPr>
+              <a:t>Meilleure compatibilité avec les exigences conformité, risque et sécurité.</a:t>
+            </a:r>
+          </a:p>
+          <a:p xmlns:a="http://schemas.openxmlformats.org/drawingml/2006/main">
+            <a:pPr marL="24" indent="-14" algn="l">
+              <a:lnSpc>
+                <a:spcPct val="115000"/>
+              </a:lnSpc>
+              <a:buNone/>
+              <a:defRPr sz="1275" b="0">
+                <a:solidFill>
+                  <a:srgbClr val="222222"/>
+                </a:solidFill>
+                <a:latin typeface="Helvetica Neue"/>
+                <a:ea typeface="Helvetica Neue"/>
+                <a:cs typeface="Helvetica Neue"/>
+              </a:defRPr>
+            </a:pPr>
+            <a:r>
+              <a:rPr sz="1275" b="0">
+                <a:solidFill>
+                  <a:srgbClr val="222222"/>
+                </a:solidFill>
+                <a:latin typeface="Helvetica Neue"/>
+                <a:ea typeface="Helvetica Neue"/>
+                <a:cs typeface="Helvetica Neue"/>
+              </a:rPr>
+              <a:t>Validation humaine maintenue avant diffusion, arbitrage ou usage officiel.</a:t>
+            </a:r>
+          </a:p>
+        </p:txBody>
+      </p:sp>
+      <p:sp>
+        <p:nvSpPr>
+          <p:cNvPr id="11" name="guardrail-bar">
+            <a:extLst xmlns:a="http://schemas.openxmlformats.org/drawingml/2006/main">
+              <a:ext uri="{FF2B5EF4-FFF2-40B4-BE49-F238E27FC236}">
+                <a16:creationId xmlns:a16="http://schemas.microsoft.com/office/drawing/2014/main" id="{070AC274-CA8C-4D59-ABC5-42DBF5FCB963}"/>
+              </a:ext>
+            </a:extLst>
+          </p:cNvPr>
+          <p:cNvSpPr>
+            <a:spLocks xmlns:a="http://schemas.openxmlformats.org/drawingml/2006/main" noGrp="1"/>
+          </p:cNvSpPr>
+          <p:nvPr/>
+        </p:nvSpPr>
+        <p:spPr>
+          <a:xfrm xmlns:a="http://schemas.openxmlformats.org/drawingml/2006/main">
+            <a:off x="0" y="5829300"/>
+            <a:ext cx="12192000" cy="1028700"/>
           </a:xfrm>
           <a:prstGeom xmlns:a="http://schemas.openxmlformats.org/drawingml/2006/main" prst="rect">
             <a:avLst/>
           </a:prstGeom>
           <a:solidFill xmlns:a="http://schemas.openxmlformats.org/drawingml/2006/main">
-            <a:srgbClr val="EDEDED"/>
+            <a:srgbClr val="000000"/>
           </a:solidFill>
           <a:ln xmlns:a="http://schemas.openxmlformats.org/drawingml/2006/main" w="0">
             <a:noFill/>
@@ -3373,363 +3629,22 @@
       </p:sp>
       <p:sp>
         <p:nvSpPr>
-          <p:cNvPr id="12" name="workflow-step-658">
-            <a:extLst xmlns:a="http://schemas.openxmlformats.org/drawingml/2006/main">
-              <a:ext uri="{FF2B5EF4-FFF2-40B4-BE49-F238E27FC236}">
-                <a16:creationId xmlns:a16="http://schemas.microsoft.com/office/drawing/2014/main" id="{F55CC23A-CF5A-4064-8647-B4BE51B0A517}"/>
-              </a:ext>
-            </a:extLst>
-          </p:cNvPr>
-          <p:cNvSpPr>
-            <a:spLocks xmlns:a="http://schemas.openxmlformats.org/drawingml/2006/main" noGrp="1"/>
-          </p:cNvSpPr>
-          <p:nvPr/>
-        </p:nvSpPr>
-        <p:spPr>
-          <a:xfrm xmlns:a="http://schemas.openxmlformats.org/drawingml/2006/main">
-            <a:off x="6496050" y="2057400"/>
-            <a:ext cx="2095500" cy="571500"/>
-          </a:xfrm>
-          <a:prstGeom xmlns:a="http://schemas.openxmlformats.org/drawingml/2006/main" prst="rect">
-            <a:avLst/>
-          </a:prstGeom>
-          <a:noFill xmlns:a="http://schemas.openxmlformats.org/drawingml/2006/main"/>
-          <a:ln xmlns:a="http://schemas.openxmlformats.org/drawingml/2006/main" w="0">
-            <a:noFill/>
-            <a:prstDash val="solid"/>
-          </a:ln>
-        </p:spPr>
-        <p:txBody>
-          <a:bodyPr xmlns:a="http://schemas.openxmlformats.org/drawingml/2006/main" wrap="square" lIns="0" tIns="0" rIns="0" bIns="0" anchor="t">
-            <a:normAutofit fontScale="100000"/>
-          </a:bodyPr>
-          <a:lstStyle xmlns:a="http://schemas.openxmlformats.org/drawingml/2006/main"/>
-          <a:p xmlns:a="http://schemas.openxmlformats.org/drawingml/2006/main">
-            <a:pPr algn="l">
-              <a:lnSpc>
-                <a:spcPct val="102000"/>
-              </a:lnSpc>
-              <a:buNone/>
-              <a:defRPr sz="2025" b="0">
-                <a:solidFill>
-                  <a:srgbClr val="000000"/>
-                </a:solidFill>
-                <a:latin typeface="Helvetica Neue"/>
-                <a:ea typeface="Helvetica Neue"/>
-                <a:cs typeface="Helvetica Neue"/>
-              </a:defRPr>
-            </a:pPr>
-            <a:r>
-              <a:rPr sz="2025" b="0">
-                <a:solidFill>
-                  <a:srgbClr val="000000"/>
-                </a:solidFill>
-                <a:latin typeface="Helvetica Neue"/>
-                <a:ea typeface="Helvetica Neue"/>
-                <a:cs typeface="Helvetica Neue"/>
-              </a:rPr>
-              <a:t>3. Synthèse IA</a:t>
-            </a:r>
-          </a:p>
-        </p:txBody>
-      </p:sp>
-      <p:sp>
-        <p:nvSpPr>
-          <p:cNvPr id="13" name="workflow-body-658">
-            <a:extLst xmlns:a="http://schemas.openxmlformats.org/drawingml/2006/main">
-              <a:ext uri="{FF2B5EF4-FFF2-40B4-BE49-F238E27FC236}">
-                <a16:creationId xmlns:a16="http://schemas.microsoft.com/office/drawing/2014/main" id="{A98A770D-ED3D-4A45-A38E-D9BCCAFC1C12}"/>
-              </a:ext>
-            </a:extLst>
-          </p:cNvPr>
-          <p:cNvSpPr>
-            <a:spLocks xmlns:a="http://schemas.openxmlformats.org/drawingml/2006/main" noGrp="1"/>
-          </p:cNvSpPr>
-          <p:nvPr/>
-        </p:nvSpPr>
-        <p:spPr>
-          <a:xfrm xmlns:a="http://schemas.openxmlformats.org/drawingml/2006/main">
-            <a:off x="6496050" y="3124200"/>
-            <a:ext cx="2095500" cy="1257300"/>
-          </a:xfrm>
-          <a:prstGeom xmlns:a="http://schemas.openxmlformats.org/drawingml/2006/main" prst="rect">
-            <a:avLst/>
-          </a:prstGeom>
-          <a:noFill xmlns:a="http://schemas.openxmlformats.org/drawingml/2006/main"/>
-          <a:ln xmlns:a="http://schemas.openxmlformats.org/drawingml/2006/main" w="0">
-            <a:noFill/>
-            <a:prstDash val="solid"/>
-          </a:ln>
-        </p:spPr>
-        <p:txBody>
-          <a:bodyPr xmlns:a="http://schemas.openxmlformats.org/drawingml/2006/main" wrap="square" lIns="0" tIns="0" rIns="0" bIns="0" anchor="t">
-            <a:normAutofit fontScale="100000"/>
-          </a:bodyPr>
-          <a:lstStyle xmlns:a="http://schemas.openxmlformats.org/drawingml/2006/main"/>
-          <a:p xmlns:a="http://schemas.openxmlformats.org/drawingml/2006/main">
-            <a:pPr algn="l">
-              <a:lnSpc>
-                <a:spcPct val="116000"/>
-              </a:lnSpc>
-              <a:buNone/>
-              <a:defRPr sz="1350" b="0">
-                <a:solidFill>
-                  <a:srgbClr val="222222"/>
-                </a:solidFill>
-                <a:latin typeface="Helvetica Neue"/>
-                <a:ea typeface="Helvetica Neue"/>
-                <a:cs typeface="Helvetica Neue"/>
-              </a:defRPr>
-            </a:pPr>
-            <a:r>
-              <a:rPr sz="1350" b="0">
-                <a:solidFill>
-                  <a:srgbClr val="222222"/>
-                </a:solidFill>
-                <a:latin typeface="Helvetica Neue"/>
-                <a:ea typeface="Helvetica Neue"/>
-                <a:cs typeface="Helvetica Neue"/>
-              </a:rPr>
-              <a:t>L’IA rédige un commentaire clair en français professionnel pour accélérer la lecture managériale.</a:t>
-            </a:r>
-          </a:p>
-        </p:txBody>
-      </p:sp>
-      <p:sp>
-        <p:nvSpPr>
-          <p:cNvPr id="14" name="workflow-panel-966">
-            <a:extLst xmlns:a="http://schemas.openxmlformats.org/drawingml/2006/main">
-              <a:ext uri="{FF2B5EF4-FFF2-40B4-BE49-F238E27FC236}">
-                <a16:creationId xmlns:a16="http://schemas.microsoft.com/office/drawing/2014/main" id="{57F36017-32FC-4DFB-B737-FBD724FC19C2}"/>
-              </a:ext>
-            </a:extLst>
-          </p:cNvPr>
-          <p:cNvSpPr>
-            <a:spLocks xmlns:a="http://schemas.openxmlformats.org/drawingml/2006/main" noGrp="1"/>
-          </p:cNvSpPr>
-          <p:nvPr/>
-        </p:nvSpPr>
-        <p:spPr>
-          <a:xfrm xmlns:a="http://schemas.openxmlformats.org/drawingml/2006/main">
-            <a:off x="9201150" y="1771650"/>
-            <a:ext cx="2590800" cy="3105150"/>
-          </a:xfrm>
-          <a:prstGeom xmlns:a="http://schemas.openxmlformats.org/drawingml/2006/main" prst="rect">
-            <a:avLst/>
-          </a:prstGeom>
-          <a:solidFill xmlns:a="http://schemas.openxmlformats.org/drawingml/2006/main">
-            <a:srgbClr val="EDEDED"/>
-          </a:solidFill>
-          <a:ln xmlns:a="http://schemas.openxmlformats.org/drawingml/2006/main" w="0">
-            <a:noFill/>
-            <a:prstDash val="solid"/>
-          </a:ln>
-        </p:spPr>
-      </p:sp>
-      <p:sp>
-        <p:nvSpPr>
-          <p:cNvPr id="15" name="workflow-step-966">
-            <a:extLst xmlns:a="http://schemas.openxmlformats.org/drawingml/2006/main">
-              <a:ext uri="{FF2B5EF4-FFF2-40B4-BE49-F238E27FC236}">
-                <a16:creationId xmlns:a16="http://schemas.microsoft.com/office/drawing/2014/main" id="{2EE42E4D-50A1-45C0-A31C-DC3E9D0B69A9}"/>
-              </a:ext>
-            </a:extLst>
-          </p:cNvPr>
-          <p:cNvSpPr>
-            <a:spLocks xmlns:a="http://schemas.openxmlformats.org/drawingml/2006/main" noGrp="1"/>
-          </p:cNvSpPr>
-          <p:nvPr/>
-        </p:nvSpPr>
-        <p:spPr>
-          <a:xfrm xmlns:a="http://schemas.openxmlformats.org/drawingml/2006/main">
-            <a:off x="9429750" y="2057400"/>
-            <a:ext cx="2095500" cy="571500"/>
-          </a:xfrm>
-          <a:prstGeom xmlns:a="http://schemas.openxmlformats.org/drawingml/2006/main" prst="rect">
-            <a:avLst/>
-          </a:prstGeom>
-          <a:noFill xmlns:a="http://schemas.openxmlformats.org/drawingml/2006/main"/>
-          <a:ln xmlns:a="http://schemas.openxmlformats.org/drawingml/2006/main" w="0">
-            <a:noFill/>
-            <a:prstDash val="solid"/>
-          </a:ln>
-        </p:spPr>
-        <p:txBody>
-          <a:bodyPr xmlns:a="http://schemas.openxmlformats.org/drawingml/2006/main" wrap="square" lIns="0" tIns="0" rIns="0" bIns="0" anchor="t">
-            <a:normAutofit fontScale="90777"/>
-          </a:bodyPr>
-          <a:lstStyle xmlns:a="http://schemas.openxmlformats.org/drawingml/2006/main"/>
-          <a:p xmlns:a="http://schemas.openxmlformats.org/drawingml/2006/main">
-            <a:pPr algn="l">
-              <a:lnSpc>
-                <a:spcPct val="102000"/>
-              </a:lnSpc>
-              <a:buNone/>
-              <a:defRPr sz="2025" b="0">
-                <a:solidFill>
-                  <a:srgbClr val="000000"/>
-                </a:solidFill>
-                <a:latin typeface="Helvetica Neue"/>
-                <a:ea typeface="Helvetica Neue"/>
-                <a:cs typeface="Helvetica Neue"/>
-              </a:defRPr>
-            </a:pPr>
-            <a:r>
-              <a:rPr sz="2025" b="0">
-                <a:solidFill>
-                  <a:srgbClr val="000000"/>
-                </a:solidFill>
-                <a:latin typeface="Helvetica Neue"/>
-                <a:ea typeface="Helvetica Neue"/>
-                <a:cs typeface="Helvetica Neue"/>
-              </a:rPr>
-              <a:t>4. Validation et diffusion</a:t>
-            </a:r>
-          </a:p>
-        </p:txBody>
-      </p:sp>
-      <p:sp>
-        <p:nvSpPr>
-          <p:cNvPr id="16" name="workflow-body-966">
-            <a:extLst xmlns:a="http://schemas.openxmlformats.org/drawingml/2006/main">
-              <a:ext uri="{FF2B5EF4-FFF2-40B4-BE49-F238E27FC236}">
-                <a16:creationId xmlns:a16="http://schemas.microsoft.com/office/drawing/2014/main" id="{44B59586-4410-4B2A-A4B2-53C4E4006163}"/>
-              </a:ext>
-            </a:extLst>
-          </p:cNvPr>
-          <p:cNvSpPr>
-            <a:spLocks xmlns:a="http://schemas.openxmlformats.org/drawingml/2006/main" noGrp="1"/>
-          </p:cNvSpPr>
-          <p:nvPr/>
-        </p:nvSpPr>
-        <p:spPr>
-          <a:xfrm xmlns:a="http://schemas.openxmlformats.org/drawingml/2006/main">
-            <a:off x="9429750" y="3124200"/>
-            <a:ext cx="2095500" cy="1257300"/>
-          </a:xfrm>
-          <a:prstGeom xmlns:a="http://schemas.openxmlformats.org/drawingml/2006/main" prst="rect">
-            <a:avLst/>
-          </a:prstGeom>
-          <a:noFill xmlns:a="http://schemas.openxmlformats.org/drawingml/2006/main"/>
-          <a:ln xmlns:a="http://schemas.openxmlformats.org/drawingml/2006/main" w="0">
-            <a:noFill/>
-            <a:prstDash val="solid"/>
-          </a:ln>
-        </p:spPr>
-        <p:txBody>
-          <a:bodyPr xmlns:a="http://schemas.openxmlformats.org/drawingml/2006/main" wrap="square" lIns="0" tIns="0" rIns="0" bIns="0" anchor="t">
-            <a:normAutofit fontScale="100000"/>
-          </a:bodyPr>
-          <a:lstStyle xmlns:a="http://schemas.openxmlformats.org/drawingml/2006/main"/>
-          <a:p xmlns:a="http://schemas.openxmlformats.org/drawingml/2006/main">
-            <a:pPr algn="l">
-              <a:lnSpc>
-                <a:spcPct val="116000"/>
-              </a:lnSpc>
-              <a:buNone/>
-              <a:defRPr sz="1350" b="0">
-                <a:solidFill>
-                  <a:srgbClr val="222222"/>
-                </a:solidFill>
-                <a:latin typeface="Helvetica Neue"/>
-                <a:ea typeface="Helvetica Neue"/>
-                <a:cs typeface="Helvetica Neue"/>
-              </a:defRPr>
-            </a:pPr>
-            <a:r>
-              <a:rPr sz="1350" b="0">
-                <a:solidFill>
-                  <a:srgbClr val="222222"/>
-                </a:solidFill>
-                <a:latin typeface="Helvetica Neue"/>
-                <a:ea typeface="Helvetica Neue"/>
-                <a:cs typeface="Helvetica Neue"/>
-              </a:rPr>
-              <a:t>Un responsable relit, valide puis transmet la version finale au contrôle financier, à la comptabilité ou au comité.</a:t>
-            </a:r>
-          </a:p>
-        </p:txBody>
-      </p:sp>
-      <p:sp>
-        <p:nvSpPr>
-          <p:cNvPr id="17" name="workflow-footer">
-            <a:extLst xmlns:a="http://schemas.openxmlformats.org/drawingml/2006/main">
-              <a:ext uri="{FF2B5EF4-FFF2-40B4-BE49-F238E27FC236}">
-                <a16:creationId xmlns:a16="http://schemas.microsoft.com/office/drawing/2014/main" id="{4846E6DB-CCFF-4FF9-A3A2-D88C9F8CA5DA}"/>
-              </a:ext>
-            </a:extLst>
-          </p:cNvPr>
-          <p:cNvSpPr>
-            <a:spLocks xmlns:a="http://schemas.openxmlformats.org/drawingml/2006/main" noGrp="1"/>
-          </p:cNvSpPr>
-          <p:nvPr/>
-        </p:nvSpPr>
-        <p:spPr>
-          <a:xfrm xmlns:a="http://schemas.openxmlformats.org/drawingml/2006/main">
-            <a:off x="400050" y="5381625"/>
-            <a:ext cx="11334750" cy="323850"/>
-          </a:xfrm>
-          <a:prstGeom xmlns:a="http://schemas.openxmlformats.org/drawingml/2006/main" prst="rect">
-            <a:avLst/>
-          </a:prstGeom>
-          <a:noFill xmlns:a="http://schemas.openxmlformats.org/drawingml/2006/main"/>
-          <a:ln xmlns:a="http://schemas.openxmlformats.org/drawingml/2006/main" w="0">
-            <a:noFill/>
-            <a:prstDash val="solid"/>
-          </a:ln>
-        </p:spPr>
-        <p:txBody>
-          <a:bodyPr xmlns:a="http://schemas.openxmlformats.org/drawingml/2006/main" wrap="square" lIns="0" tIns="0" rIns="0" bIns="0" anchor="t">
-            <a:normAutofit fontScale="100000"/>
-          </a:bodyPr>
-          <a:lstStyle xmlns:a="http://schemas.openxmlformats.org/drawingml/2006/main"/>
-          <a:p xmlns:a="http://schemas.openxmlformats.org/drawingml/2006/main">
-            <a:pPr algn="l">
-              <a:lnSpc>
-                <a:spcPct val="108000"/>
-              </a:lnSpc>
-              <a:buNone/>
-              <a:defRPr sz="1650" b="0">
-                <a:solidFill>
-                  <a:srgbClr val="222222"/>
-                </a:solidFill>
-                <a:latin typeface="Helvetica Neue"/>
-                <a:ea typeface="Helvetica Neue"/>
-                <a:cs typeface="Helvetica Neue"/>
-              </a:defRPr>
-            </a:pPr>
-            <a:r>
-              <a:rPr sz="1650" b="0">
-                <a:solidFill>
-                  <a:srgbClr val="222222"/>
-                </a:solidFill>
-                <a:latin typeface="Helvetica Neue"/>
-                <a:ea typeface="Helvetica Neue"/>
-                <a:cs typeface="Helvetica Neue"/>
-              </a:rPr>
-              <a:t>La diffusion automatique n’intervient qu’après validation humaine.</a:t>
-            </a:r>
-          </a:p>
-        </p:txBody>
-      </p:sp>
-      <p:sp>
-        <p:nvSpPr>
-          <p:cNvPr id="18" name="footer-03">
-            <a:extLst xmlns:a="http://schemas.openxmlformats.org/drawingml/2006/main">
-              <a:ext uri="{FF2B5EF4-FFF2-40B4-BE49-F238E27FC236}">
-                <a16:creationId xmlns:a16="http://schemas.microsoft.com/office/drawing/2014/main" id="{C34B5965-316A-4958-B9FD-C0338B72AFF4}"/>
-              </a:ext>
-            </a:extLst>
-          </p:cNvPr>
-          <p:cNvSpPr>
-            <a:spLocks xmlns:a="http://schemas.openxmlformats.org/drawingml/2006/main" noGrp="1"/>
-          </p:cNvSpPr>
-          <p:nvPr/>
-        </p:nvSpPr>
-        <p:spPr>
-          <a:xfrm xmlns:a="http://schemas.openxmlformats.org/drawingml/2006/main">
-            <a:off x="11220450" y="6276975"/>
-            <a:ext cx="533400" cy="209550"/>
+          <p:cNvPr id="12" name="guardrail-text">
+            <a:extLst xmlns:a="http://schemas.openxmlformats.org/drawingml/2006/main">
+              <a:ext uri="{FF2B5EF4-FFF2-40B4-BE49-F238E27FC236}">
+                <a16:creationId xmlns:a16="http://schemas.microsoft.com/office/drawing/2014/main" id="{1CBA9352-BA90-42B4-8F3C-06E340D3EAE3}"/>
+              </a:ext>
+            </a:extLst>
+          </p:cNvPr>
+          <p:cNvSpPr>
+            <a:spLocks xmlns:a="http://schemas.openxmlformats.org/drawingml/2006/main" noGrp="1"/>
+          </p:cNvSpPr>
+          <p:nvPr/>
+        </p:nvSpPr>
+        <p:spPr>
+          <a:xfrm xmlns:a="http://schemas.openxmlformats.org/drawingml/2006/main">
+            <a:off x="400050" y="6143625"/>
+            <a:ext cx="10668000" cy="285750"/>
           </a:xfrm>
           <a:prstGeom xmlns:a="http://schemas.openxmlformats.org/drawingml/2006/main" prst="rect">
             <a:avLst/>
@@ -3746,6 +3661,68 @@
           </a:bodyPr>
           <a:lstStyle xmlns:a="http://schemas.openxmlformats.org/drawingml/2006/main"/>
           <a:p xmlns:a="http://schemas.openxmlformats.org/drawingml/2006/main">
+            <a:pPr algn="l">
+              <a:lnSpc>
+                <a:spcPct val="108000"/>
+              </a:lnSpc>
+              <a:buNone/>
+              <a:defRPr sz="1725" b="0">
+                <a:solidFill>
+                  <a:srgbClr val="FFFFFF"/>
+                </a:solidFill>
+                <a:latin typeface="Helvetica Neue"/>
+                <a:ea typeface="Helvetica Neue"/>
+                <a:cs typeface="Helvetica Neue"/>
+              </a:defRPr>
+            </a:pPr>
+            <a:r>
+              <a:rPr sz="1725" b="0">
+                <a:solidFill>
+                  <a:srgbClr val="FFFFFF"/>
+                </a:solidFill>
+                <a:latin typeface="Helvetica Neue"/>
+                <a:ea typeface="Helvetica Neue"/>
+                <a:cs typeface="Helvetica Neue"/>
+              </a:rPr>
+              <a:t>Garde-fou : pseudonymisation avant l’IA et validation humaine obligatoire avant toute diffusion.</a:t>
+            </a:r>
+          </a:p>
+        </p:txBody>
+      </p:sp>
+      <p:sp>
+        <p:nvSpPr>
+          <p:cNvPr id="13" name="footer-02">
+            <a:extLst xmlns:a="http://schemas.openxmlformats.org/drawingml/2006/main">
+              <a:ext uri="{FF2B5EF4-FFF2-40B4-BE49-F238E27FC236}">
+                <a16:creationId xmlns:a16="http://schemas.microsoft.com/office/drawing/2014/main" id="{0AD0A1D4-5C27-473A-B688-CFD6228A70D4}"/>
+              </a:ext>
+            </a:extLst>
+          </p:cNvPr>
+          <p:cNvSpPr>
+            <a:spLocks xmlns:a="http://schemas.openxmlformats.org/drawingml/2006/main" noGrp="1"/>
+          </p:cNvSpPr>
+          <p:nvPr/>
+        </p:nvSpPr>
+        <p:spPr>
+          <a:xfrm xmlns:a="http://schemas.openxmlformats.org/drawingml/2006/main">
+            <a:off x="11220450" y="6276975"/>
+            <a:ext cx="533400" cy="209550"/>
+          </a:xfrm>
+          <a:prstGeom xmlns:a="http://schemas.openxmlformats.org/drawingml/2006/main" prst="rect">
+            <a:avLst/>
+          </a:prstGeom>
+          <a:noFill xmlns:a="http://schemas.openxmlformats.org/drawingml/2006/main"/>
+          <a:ln xmlns:a="http://schemas.openxmlformats.org/drawingml/2006/main" w="0">
+            <a:noFill/>
+            <a:prstDash val="solid"/>
+          </a:ln>
+        </p:spPr>
+        <p:txBody>
+          <a:bodyPr xmlns:a="http://schemas.openxmlformats.org/drawingml/2006/main" wrap="square" lIns="0" tIns="0" rIns="0" bIns="0" anchor="t">
+            <a:noAutofit/>
+          </a:bodyPr>
+          <a:lstStyle xmlns:a="http://schemas.openxmlformats.org/drawingml/2006/main"/>
+          <a:p xmlns:a="http://schemas.openxmlformats.org/drawingml/2006/main">
             <a:pPr algn="r">
               <a:lnSpc>
                 <a:spcPct val="108000"/>
@@ -3777,7 +3754,7 @@
     </p:spTree>
     <p:extLst>
       <p:ext uri="{BB962C8B-B14F-4D97-AF65-F5344CB8AC3E}">
-        <p14:creationId xmlns:p14="http://schemas.microsoft.com/office/powerpoint/2010/main" val="454270334"/>
+        <p14:creationId xmlns:p14="http://schemas.microsoft.com/office/powerpoint/2010/main" val="448017883"/>
       </p:ext>
     </p:extLst>
   </p:cSld>
@@ -3805,10 +3782,10 @@
       </p:grpSpPr>
       <p:sp>
         <p:nvSpPr>
-          <p:cNvPr id="1" name="section-Bénéfices">
-            <a:extLst xmlns:a="http://schemas.openxmlformats.org/drawingml/2006/main">
-              <a:ext uri="{FF2B5EF4-FFF2-40B4-BE49-F238E27FC236}">
-                <a16:creationId xmlns:a16="http://schemas.microsoft.com/office/drawing/2014/main" id="{0707F894-E914-4C20-A24C-F2F898213CE9}"/>
+          <p:cNvPr id="1" name="section-Workflow">
+            <a:extLst xmlns:a="http://schemas.openxmlformats.org/drawingml/2006/main">
+              <a:ext uri="{FF2B5EF4-FFF2-40B4-BE49-F238E27FC236}">
+                <a16:creationId xmlns:a16="http://schemas.microsoft.com/office/drawing/2014/main" id="{ADC18810-A9B0-4165-9919-E618AE857868}"/>
               </a:ext>
             </a:extLst>
           </p:cNvPr>
@@ -3860,21 +3837,21 @@
                 <a:ea typeface="Helvetica Neue"/>
                 <a:cs typeface="Helvetica Neue"/>
               </a:rPr>
-              <a:t>Bénéfices</a:t>
+              <a:t>Workflow</a:t>
             </a:r>
           </a:p>
         </p:txBody>
       </p:sp>
       <p:pic>
         <p:nvPicPr>
-          <p:cNvPr id="14" name=""/>
+          <p:cNvPr id="21" name=""/>
           <p:cNvPicPr>
             <a:picLocks xmlns:a="http://schemas.openxmlformats.org/drawingml/2006/main" noChangeAspect="1"/>
           </p:cNvPicPr>
           <p:nvPr/>
         </p:nvPicPr>
         <p:blipFill>
-          <a:blip xmlns:r="http://schemas.openxmlformats.org/officeDocument/2006/relationships" xmlns:a="http://schemas.openxmlformats.org/drawingml/2006/main" r:embed="R3a86ccb7410b47b6"/>
+          <a:blip xmlns:r="http://schemas.openxmlformats.org/officeDocument/2006/relationships" xmlns:a="http://schemas.openxmlformats.org/drawingml/2006/main" r:embed="Rfa76ab2850f04787"/>
           <a:stretch xmlns:a="http://schemas.openxmlformats.org/drawingml/2006/main"/>
         </p:blipFill>
         <p:spPr>
@@ -3889,10 +3866,10 @@
       </p:pic>
       <p:sp>
         <p:nvSpPr>
-          <p:cNvPr id="3" name="benefits-title">
-            <a:extLst xmlns:a="http://schemas.openxmlformats.org/drawingml/2006/main">
-              <a:ext uri="{FF2B5EF4-FFF2-40B4-BE49-F238E27FC236}">
-                <a16:creationId xmlns:a16="http://schemas.microsoft.com/office/drawing/2014/main" id="{17616589-F9F5-4016-94B5-2E54D153B706}"/>
+          <p:cNvPr id="3" name="workflow-title">
+            <a:extLst xmlns:a="http://schemas.openxmlformats.org/drawingml/2006/main">
+              <a:ext uri="{FF2B5EF4-FFF2-40B4-BE49-F238E27FC236}">
+                <a16:creationId xmlns:a16="http://schemas.microsoft.com/office/drawing/2014/main" id="{A106B2F9-8159-4744-A9DC-41956514CDE3}"/>
               </a:ext>
             </a:extLst>
           </p:cNvPr>
@@ -3904,7 +3881,7 @@
         <p:spPr>
           <a:xfrm xmlns:a="http://schemas.openxmlformats.org/drawingml/2006/main">
             <a:off x="400050" y="342900"/>
-            <a:ext cx="10668000" cy="742950"/>
+            <a:ext cx="10572750" cy="666750"/>
           </a:xfrm>
           <a:prstGeom xmlns:a="http://schemas.openxmlformats.org/drawingml/2006/main" prst="rect">
             <a:avLst/>
@@ -3917,13 +3894,13 @@
         </p:spPr>
         <p:txBody>
           <a:bodyPr xmlns:a="http://schemas.openxmlformats.org/drawingml/2006/main" wrap="square" lIns="0" tIns="0" rIns="0" bIns="0" anchor="t">
-            <a:normAutofit fontScale="83333"/>
+            <a:normAutofit fontScale="96832"/>
           </a:bodyPr>
           <a:lstStyle xmlns:a="http://schemas.openxmlformats.org/drawingml/2006/main"/>
           <a:p xmlns:a="http://schemas.openxmlformats.org/drawingml/2006/main">
             <a:pPr algn="l">
               <a:lnSpc>
-                <a:spcPct val="100000"/>
+                <a:spcPct val="108000"/>
               </a:lnSpc>
               <a:buNone/>
               <a:defRPr sz="2925" b="0">
@@ -3944,29 +3921,29 @@
                 <a:ea typeface="Helvetica Neue"/>
                 <a:cs typeface="Helvetica Neue"/>
               </a:rPr>
-              <a:t>Le gain vient d’abord de la vitesse, de l’homogénéité et d’une revue plus précoce</a:t>
-            </a:r>
-          </a:p>
-        </p:txBody>
-      </p:sp>
-      <p:sp>
-        <p:nvSpPr>
-          <p:cNvPr id="4" name="benefits-intro">
-            <a:extLst xmlns:a="http://schemas.openxmlformats.org/drawingml/2006/main">
-              <a:ext uri="{FF2B5EF4-FFF2-40B4-BE49-F238E27FC236}">
-                <a16:creationId xmlns:a16="http://schemas.microsoft.com/office/drawing/2014/main" id="{5E032665-3E00-4651-96A3-87E7EBCA645D}"/>
-              </a:ext>
-            </a:extLst>
-          </p:cNvPr>
-          <p:cNvSpPr>
-            <a:spLocks xmlns:a="http://schemas.openxmlformats.org/drawingml/2006/main" noGrp="1"/>
-          </p:cNvSpPr>
-          <p:nvPr/>
-        </p:nvSpPr>
-        <p:spPr>
-          <a:xfrm xmlns:a="http://schemas.openxmlformats.org/drawingml/2006/main">
-            <a:off x="400050" y="1181100"/>
-            <a:ext cx="10668000" cy="552450"/>
+              <a:t>Le workflow reste simple à expliquer et crédible en démonstration</a:t>
+            </a:r>
+          </a:p>
+        </p:txBody>
+      </p:sp>
+      <p:sp>
+        <p:nvSpPr>
+          <p:cNvPr id="4" name="workflow-intro">
+            <a:extLst xmlns:a="http://schemas.openxmlformats.org/drawingml/2006/main">
+              <a:ext uri="{FF2B5EF4-FFF2-40B4-BE49-F238E27FC236}">
+                <a16:creationId xmlns:a16="http://schemas.microsoft.com/office/drawing/2014/main" id="{D69BB6D7-1801-4C0B-AD55-EB5074D410E1}"/>
+              </a:ext>
+            </a:extLst>
+          </p:cNvPr>
+          <p:cNvSpPr>
+            <a:spLocks xmlns:a="http://schemas.openxmlformats.org/drawingml/2006/main" noGrp="1"/>
+          </p:cNvSpPr>
+          <p:nvPr/>
+        </p:nvSpPr>
+        <p:spPr>
+          <a:xfrm xmlns:a="http://schemas.openxmlformats.org/drawingml/2006/main">
+            <a:off x="400050" y="1123950"/>
+            <a:ext cx="10287000" cy="419100"/>
           </a:xfrm>
           <a:prstGeom xmlns:a="http://schemas.openxmlformats.org/drawingml/2006/main" prst="rect">
             <a:avLst/>
@@ -3979,13 +3956,13 @@
         </p:spPr>
         <p:txBody>
           <a:bodyPr xmlns:a="http://schemas.openxmlformats.org/drawingml/2006/main" wrap="square" lIns="0" tIns="0" rIns="0" bIns="0" anchor="t">
-            <a:normAutofit fontScale="97525"/>
+            <a:normAutofit fontScale="94336"/>
           </a:bodyPr>
           <a:lstStyle xmlns:a="http://schemas.openxmlformats.org/drawingml/2006/main"/>
           <a:p xmlns:a="http://schemas.openxmlformats.org/drawingml/2006/main">
             <a:pPr algn="l">
               <a:lnSpc>
-                <a:spcPct val="118000"/>
+                <a:spcPct val="108000"/>
               </a:lnSpc>
               <a:buNone/>
               <a:defRPr sz="1575" b="0">
@@ -4006,29 +3983,29 @@
                 <a:ea typeface="Helvetica Neue"/>
                 <a:cs typeface="Helvetica Neue"/>
               </a:rPr>
-              <a:t>Le cas d’usage n’essaie pas de remplacer le jugement financier. Il réduit les tâches de reprise, améliore la lisibilité des écarts et prépare mieux les arbitrages.</a:t>
-            </a:r>
-          </a:p>
-        </p:txBody>
-      </p:sp>
-      <p:sp>
-        <p:nvSpPr>
-          <p:cNvPr id="5" name="before-panel">
-            <a:extLst xmlns:a="http://schemas.openxmlformats.org/drawingml/2006/main">
-              <a:ext uri="{FF2B5EF4-FFF2-40B4-BE49-F238E27FC236}">
-                <a16:creationId xmlns:a16="http://schemas.microsoft.com/office/drawing/2014/main" id="{BF31BA90-495C-41E6-B08A-40A64C5589D9}"/>
-              </a:ext>
-            </a:extLst>
-          </p:cNvPr>
-          <p:cNvSpPr>
-            <a:spLocks xmlns:a="http://schemas.openxmlformats.org/drawingml/2006/main" noGrp="1"/>
-          </p:cNvSpPr>
-          <p:nvPr/>
-        </p:nvSpPr>
-        <p:spPr>
-          <a:xfrm xmlns:a="http://schemas.openxmlformats.org/drawingml/2006/main">
-            <a:off x="400050" y="2190750"/>
-            <a:ext cx="5534025" cy="2647950"/>
+              <a:t>Le scénario présenté peut rester très opérationnel : dépôt du fichier, contrôles, synthèse IA, puis validation avant diffusion.</a:t>
+            </a:r>
+          </a:p>
+        </p:txBody>
+      </p:sp>
+      <p:sp>
+        <p:nvSpPr>
+          <p:cNvPr id="5" name="workflow-panel-42">
+            <a:extLst xmlns:a="http://schemas.openxmlformats.org/drawingml/2006/main">
+              <a:ext uri="{FF2B5EF4-FFF2-40B4-BE49-F238E27FC236}">
+                <a16:creationId xmlns:a16="http://schemas.microsoft.com/office/drawing/2014/main" id="{8D665570-C736-4FC8-AA00-EC1FEC85A9F4}"/>
+              </a:ext>
+            </a:extLst>
+          </p:cNvPr>
+          <p:cNvSpPr>
+            <a:spLocks xmlns:a="http://schemas.openxmlformats.org/drawingml/2006/main" noGrp="1"/>
+          </p:cNvSpPr>
+          <p:nvPr/>
+        </p:nvSpPr>
+        <p:spPr>
+          <a:xfrm xmlns:a="http://schemas.openxmlformats.org/drawingml/2006/main">
+            <a:off x="400050" y="1771650"/>
+            <a:ext cx="2590800" cy="3105150"/>
           </a:xfrm>
           <a:prstGeom xmlns:a="http://schemas.openxmlformats.org/drawingml/2006/main" prst="rect">
             <a:avLst/>
@@ -4044,22 +4021,22 @@
       </p:sp>
       <p:sp>
         <p:nvSpPr>
-          <p:cNvPr id="6" name="before-title">
-            <a:extLst xmlns:a="http://schemas.openxmlformats.org/drawingml/2006/main">
-              <a:ext uri="{FF2B5EF4-FFF2-40B4-BE49-F238E27FC236}">
-                <a16:creationId xmlns:a16="http://schemas.microsoft.com/office/drawing/2014/main" id="{1D30D9EF-DECC-4CF7-B51A-58DB08F0D97C}"/>
-              </a:ext>
-            </a:extLst>
-          </p:cNvPr>
-          <p:cNvSpPr>
-            <a:spLocks xmlns:a="http://schemas.openxmlformats.org/drawingml/2006/main" noGrp="1"/>
-          </p:cNvSpPr>
-          <p:nvPr/>
-        </p:nvSpPr>
-        <p:spPr>
-          <a:xfrm xmlns:a="http://schemas.openxmlformats.org/drawingml/2006/main">
-            <a:off x="695325" y="2457450"/>
-            <a:ext cx="1238250" cy="323850"/>
+          <p:cNvPr id="6" name="workflow-step-42">
+            <a:extLst xmlns:a="http://schemas.openxmlformats.org/drawingml/2006/main">
+              <a:ext uri="{FF2B5EF4-FFF2-40B4-BE49-F238E27FC236}">
+                <a16:creationId xmlns:a16="http://schemas.microsoft.com/office/drawing/2014/main" id="{0D88EA9F-1AB6-477A-84FE-BD1DDD67C9FD}"/>
+              </a:ext>
+            </a:extLst>
+          </p:cNvPr>
+          <p:cNvSpPr>
+            <a:spLocks xmlns:a="http://schemas.openxmlformats.org/drawingml/2006/main" noGrp="1"/>
+          </p:cNvSpPr>
+          <p:nvPr/>
+        </p:nvSpPr>
+        <p:spPr>
+          <a:xfrm xmlns:a="http://schemas.openxmlformats.org/drawingml/2006/main">
+            <a:off x="628650" y="2057400"/>
+            <a:ext cx="2095500" cy="571500"/>
           </a:xfrm>
           <a:prstGeom xmlns:a="http://schemas.openxmlformats.org/drawingml/2006/main" prst="rect">
             <a:avLst/>
@@ -4072,16 +4049,16 @@
         </p:spPr>
         <p:txBody>
           <a:bodyPr xmlns:a="http://schemas.openxmlformats.org/drawingml/2006/main" wrap="square" lIns="0" tIns="0" rIns="0" bIns="0" anchor="t">
-            <a:normAutofit fontScale="87449"/>
+            <a:normAutofit fontScale="90777"/>
           </a:bodyPr>
           <a:lstStyle xmlns:a="http://schemas.openxmlformats.org/drawingml/2006/main"/>
           <a:p xmlns:a="http://schemas.openxmlformats.org/drawingml/2006/main">
             <a:pPr algn="l">
               <a:lnSpc>
-                <a:spcPct val="108000"/>
-              </a:lnSpc>
-              <a:buNone/>
-              <a:defRPr sz="2250" b="0">
+                <a:spcPct val="102000"/>
+              </a:lnSpc>
+              <a:buNone/>
+              <a:defRPr sz="2025" b="0">
                 <a:solidFill>
                   <a:srgbClr val="000000"/>
                 </a:solidFill>
@@ -4091,7 +4068,7 @@
               </a:defRPr>
             </a:pPr>
             <a:r>
-              <a:rPr sz="2250" b="0">
+              <a:rPr sz="2025" b="0">
                 <a:solidFill>
                   <a:srgbClr val="000000"/>
                 </a:solidFill>
@@ -4099,29 +4076,29 @@
                 <a:ea typeface="Helvetica Neue"/>
                 <a:cs typeface="Helvetica Neue"/>
               </a:rPr>
-              <a:t>Avant</a:t>
-            </a:r>
-          </a:p>
-        </p:txBody>
-      </p:sp>
-      <p:sp>
-        <p:nvSpPr>
-          <p:cNvPr id="7" name="before-bullets">
-            <a:extLst xmlns:a="http://schemas.openxmlformats.org/drawingml/2006/main">
-              <a:ext uri="{FF2B5EF4-FFF2-40B4-BE49-F238E27FC236}">
-                <a16:creationId xmlns:a16="http://schemas.microsoft.com/office/drawing/2014/main" id="{3ED9379E-BDA5-40B6-851D-D72A7F812CAA}"/>
-              </a:ext>
-            </a:extLst>
-          </p:cNvPr>
-          <p:cNvSpPr>
-            <a:spLocks xmlns:a="http://schemas.openxmlformats.org/drawingml/2006/main" noGrp="1"/>
-          </p:cNvSpPr>
-          <p:nvPr/>
-        </p:nvSpPr>
-        <p:spPr>
-          <a:xfrm xmlns:a="http://schemas.openxmlformats.org/drawingml/2006/main">
-            <a:off x="695325" y="2990850"/>
-            <a:ext cx="4857750" cy="1428750"/>
+              <a:t>1. Dépôt des données</a:t>
+            </a:r>
+          </a:p>
+        </p:txBody>
+      </p:sp>
+      <p:sp>
+        <p:nvSpPr>
+          <p:cNvPr id="7" name="workflow-body-42">
+            <a:extLst xmlns:a="http://schemas.openxmlformats.org/drawingml/2006/main">
+              <a:ext uri="{FF2B5EF4-FFF2-40B4-BE49-F238E27FC236}">
+                <a16:creationId xmlns:a16="http://schemas.microsoft.com/office/drawing/2014/main" id="{2488F420-3F66-4ED8-99B8-B6657335411C}"/>
+              </a:ext>
+            </a:extLst>
+          </p:cNvPr>
+          <p:cNvSpPr>
+            <a:spLocks xmlns:a="http://schemas.openxmlformats.org/drawingml/2006/main" noGrp="1"/>
+          </p:cNvSpPr>
+          <p:nvPr/>
+        </p:nvSpPr>
+        <p:spPr>
+          <a:xfrm xmlns:a="http://schemas.openxmlformats.org/drawingml/2006/main">
+            <a:off x="628650" y="3124200"/>
+            <a:ext cx="2095500" cy="1257300"/>
           </a:xfrm>
           <a:prstGeom xmlns:a="http://schemas.openxmlformats.org/drawingml/2006/main" prst="rect">
             <a:avLst/>
@@ -4134,13 +4111,13 @@
         </p:spPr>
         <p:txBody>
           <a:bodyPr xmlns:a="http://schemas.openxmlformats.org/drawingml/2006/main" wrap="square" lIns="0" tIns="0" rIns="0" bIns="0" anchor="t">
-            <a:normAutofit fontScale="99925"/>
+            <a:normAutofit fontScale="100000"/>
           </a:bodyPr>
           <a:lstStyle xmlns:a="http://schemas.openxmlformats.org/drawingml/2006/main"/>
           <a:p xmlns:a="http://schemas.openxmlformats.org/drawingml/2006/main">
-            <a:pPr marL="24" indent="-14" algn="l">
-              <a:lnSpc>
-                <a:spcPct val="115000"/>
+            <a:pPr algn="l">
+              <a:lnSpc>
+                <a:spcPct val="116000"/>
               </a:lnSpc>
               <a:buNone/>
               <a:defRPr sz="1350" b="0">
@@ -4161,110 +4138,29 @@
                 <a:ea typeface="Helvetica Neue"/>
                 <a:cs typeface="Helvetica Neue"/>
               </a:rPr>
-              <a:t>Beaucoup de temps passé à reformater et commenter les chiffres.</a:t>
-            </a:r>
-          </a:p>
-          <a:p xmlns:a="http://schemas.openxmlformats.org/drawingml/2006/main">
-            <a:pPr marL="24" indent="-14" algn="l">
-              <a:lnSpc>
-                <a:spcPct val="115000"/>
-              </a:lnSpc>
-              <a:buNone/>
-              <a:defRPr sz="1350" b="0">
-                <a:solidFill>
-                  <a:srgbClr val="222222"/>
-                </a:solidFill>
-                <a:latin typeface="Helvetica Neue"/>
-                <a:ea typeface="Helvetica Neue"/>
-                <a:cs typeface="Helvetica Neue"/>
-              </a:defRPr>
-            </a:pPr>
-            <a:r>
-              <a:rPr sz="1350" b="0">
-                <a:solidFill>
-                  <a:srgbClr val="222222"/>
-                </a:solidFill>
-                <a:latin typeface="Helvetica Neue"/>
-                <a:ea typeface="Helvetica Neue"/>
-                <a:cs typeface="Helvetica Neue"/>
-              </a:rPr>
-              <a:t>Détection plus tardive des anomalies et des justificatifs manquants.</a:t>
-            </a:r>
-          </a:p>
-          <a:p xmlns:a="http://schemas.openxmlformats.org/drawingml/2006/main">
-            <a:pPr marL="24" indent="-14" algn="l">
-              <a:lnSpc>
-                <a:spcPct val="115000"/>
-              </a:lnSpc>
-              <a:buNone/>
-              <a:defRPr sz="1350" b="0">
-                <a:solidFill>
-                  <a:srgbClr val="222222"/>
-                </a:solidFill>
-                <a:latin typeface="Helvetica Neue"/>
-                <a:ea typeface="Helvetica Neue"/>
-                <a:cs typeface="Helvetica Neue"/>
-              </a:defRPr>
-            </a:pPr>
-            <a:r>
-              <a:rPr sz="1350" b="0">
-                <a:solidFill>
-                  <a:srgbClr val="222222"/>
-                </a:solidFill>
-                <a:latin typeface="Helvetica Neue"/>
-                <a:ea typeface="Helvetica Neue"/>
-                <a:cs typeface="Helvetica Neue"/>
-              </a:rPr>
-              <a:t>Notes de synthèse variables selon les équipes et les périodes.</a:t>
-            </a:r>
-          </a:p>
-          <a:p xmlns:a="http://schemas.openxmlformats.org/drawingml/2006/main">
-            <a:pPr marL="24" indent="-14" algn="l">
-              <a:lnSpc>
-                <a:spcPct val="115000"/>
-              </a:lnSpc>
-              <a:buNone/>
-              <a:defRPr sz="1350" b="0">
-                <a:solidFill>
-                  <a:srgbClr val="222222"/>
-                </a:solidFill>
-                <a:latin typeface="Helvetica Neue"/>
-                <a:ea typeface="Helvetica Neue"/>
-                <a:cs typeface="Helvetica Neue"/>
-              </a:defRPr>
-            </a:pPr>
-            <a:r>
-              <a:rPr sz="1350" b="0">
-                <a:solidFill>
-                  <a:srgbClr val="222222"/>
-                </a:solidFill>
-                <a:latin typeface="Helvetica Neue"/>
-                <a:ea typeface="Helvetica Neue"/>
-                <a:cs typeface="Helvetica Neue"/>
-              </a:rPr>
-              <a:t>Information parfois trop brute ou trop tardive pour le comité.</a:t>
-            </a:r>
-          </a:p>
-        </p:txBody>
-      </p:sp>
-      <p:sp>
-        <p:nvSpPr>
-          <p:cNvPr id="8" name="after-panel">
-            <a:extLst xmlns:a="http://schemas.openxmlformats.org/drawingml/2006/main">
-              <a:ext uri="{FF2B5EF4-FFF2-40B4-BE49-F238E27FC236}">
-                <a16:creationId xmlns:a16="http://schemas.microsoft.com/office/drawing/2014/main" id="{86952376-4616-441B-A70A-C1B96177CF74}"/>
-              </a:ext>
-            </a:extLst>
-          </p:cNvPr>
-          <p:cNvSpPr>
-            <a:spLocks xmlns:a="http://schemas.openxmlformats.org/drawingml/2006/main" noGrp="1"/>
-          </p:cNvSpPr>
-          <p:nvPr/>
-        </p:nvSpPr>
-        <p:spPr>
-          <a:xfrm xmlns:a="http://schemas.openxmlformats.org/drawingml/2006/main">
-            <a:off x="6257925" y="2190750"/>
-            <a:ext cx="5534025" cy="2647950"/>
+              <a:t>Un export comptable, un fichier Excel ou un CSV de pré-clôture est transmis dans le workflow.</a:t>
+            </a:r>
+          </a:p>
+        </p:txBody>
+      </p:sp>
+      <p:sp>
+        <p:nvSpPr>
+          <p:cNvPr id="8" name="workflow-panel-350">
+            <a:extLst xmlns:a="http://schemas.openxmlformats.org/drawingml/2006/main">
+              <a:ext uri="{FF2B5EF4-FFF2-40B4-BE49-F238E27FC236}">
+                <a16:creationId xmlns:a16="http://schemas.microsoft.com/office/drawing/2014/main" id="{1801B570-8C2E-4106-B281-C449138A8292}"/>
+              </a:ext>
+            </a:extLst>
+          </p:cNvPr>
+          <p:cNvSpPr>
+            <a:spLocks xmlns:a="http://schemas.openxmlformats.org/drawingml/2006/main" noGrp="1"/>
+          </p:cNvSpPr>
+          <p:nvPr/>
+        </p:nvSpPr>
+        <p:spPr>
+          <a:xfrm xmlns:a="http://schemas.openxmlformats.org/drawingml/2006/main">
+            <a:off x="3333750" y="1771650"/>
+            <a:ext cx="2590800" cy="3105150"/>
           </a:xfrm>
           <a:prstGeom xmlns:a="http://schemas.openxmlformats.org/drawingml/2006/main" prst="rect">
             <a:avLst/>
@@ -4280,22 +4176,22 @@
       </p:sp>
       <p:sp>
         <p:nvSpPr>
-          <p:cNvPr id="9" name="after-title">
-            <a:extLst xmlns:a="http://schemas.openxmlformats.org/drawingml/2006/main">
-              <a:ext uri="{FF2B5EF4-FFF2-40B4-BE49-F238E27FC236}">
-                <a16:creationId xmlns:a16="http://schemas.microsoft.com/office/drawing/2014/main" id="{727DE855-58BA-463F-BF61-D642A11514F3}"/>
-              </a:ext>
-            </a:extLst>
-          </p:cNvPr>
-          <p:cNvSpPr>
-            <a:spLocks xmlns:a="http://schemas.openxmlformats.org/drawingml/2006/main" noGrp="1"/>
-          </p:cNvSpPr>
-          <p:nvPr/>
-        </p:nvSpPr>
-        <p:spPr>
-          <a:xfrm xmlns:a="http://schemas.openxmlformats.org/drawingml/2006/main">
-            <a:off x="6562725" y="2457450"/>
-            <a:ext cx="1238250" cy="323850"/>
+          <p:cNvPr id="9" name="workflow-step-350">
+            <a:extLst xmlns:a="http://schemas.openxmlformats.org/drawingml/2006/main">
+              <a:ext uri="{FF2B5EF4-FFF2-40B4-BE49-F238E27FC236}">
+                <a16:creationId xmlns:a16="http://schemas.microsoft.com/office/drawing/2014/main" id="{D279FE60-4D25-4681-8948-DDDCACA81305}"/>
+              </a:ext>
+            </a:extLst>
+          </p:cNvPr>
+          <p:cNvSpPr>
+            <a:spLocks xmlns:a="http://schemas.openxmlformats.org/drawingml/2006/main" noGrp="1"/>
+          </p:cNvSpPr>
+          <p:nvPr/>
+        </p:nvSpPr>
+        <p:spPr>
+          <a:xfrm xmlns:a="http://schemas.openxmlformats.org/drawingml/2006/main">
+            <a:off x="3562350" y="2057400"/>
+            <a:ext cx="2095500" cy="571500"/>
           </a:xfrm>
           <a:prstGeom xmlns:a="http://schemas.openxmlformats.org/drawingml/2006/main" prst="rect">
             <a:avLst/>
@@ -4308,16 +4204,16 @@
         </p:spPr>
         <p:txBody>
           <a:bodyPr xmlns:a="http://schemas.openxmlformats.org/drawingml/2006/main" wrap="square" lIns="0" tIns="0" rIns="0" bIns="0" anchor="t">
-            <a:normAutofit fontScale="87449"/>
+            <a:normAutofit fontScale="97765"/>
           </a:bodyPr>
           <a:lstStyle xmlns:a="http://schemas.openxmlformats.org/drawingml/2006/main"/>
           <a:p xmlns:a="http://schemas.openxmlformats.org/drawingml/2006/main">
             <a:pPr algn="l">
               <a:lnSpc>
-                <a:spcPct val="108000"/>
-              </a:lnSpc>
-              <a:buNone/>
-              <a:defRPr sz="2250" b="0">
+                <a:spcPct val="102000"/>
+              </a:lnSpc>
+              <a:buNone/>
+              <a:defRPr sz="2025" b="0">
                 <a:solidFill>
                   <a:srgbClr val="000000"/>
                 </a:solidFill>
@@ -4327,7 +4223,7 @@
               </a:defRPr>
             </a:pPr>
             <a:r>
-              <a:rPr sz="2250" b="0">
+              <a:rPr sz="2025" b="0">
                 <a:solidFill>
                   <a:srgbClr val="000000"/>
                 </a:solidFill>
@@ -4335,172 +4231,29 @@
                 <a:ea typeface="Helvetica Neue"/>
                 <a:cs typeface="Helvetica Neue"/>
               </a:rPr>
-              <a:t>Après</a:t>
-            </a:r>
-          </a:p>
-        </p:txBody>
-      </p:sp>
-      <p:sp>
-        <p:nvSpPr>
-          <p:cNvPr id="10" name="after-bullets">
-            <a:extLst xmlns:a="http://schemas.openxmlformats.org/drawingml/2006/main">
-              <a:ext uri="{FF2B5EF4-FFF2-40B4-BE49-F238E27FC236}">
-                <a16:creationId xmlns:a16="http://schemas.microsoft.com/office/drawing/2014/main" id="{6FA4707D-97D5-46D5-9A30-455F52CDEED3}"/>
-              </a:ext>
-            </a:extLst>
-          </p:cNvPr>
-          <p:cNvSpPr>
-            <a:spLocks xmlns:a="http://schemas.openxmlformats.org/drawingml/2006/main" noGrp="1"/>
-          </p:cNvSpPr>
-          <p:nvPr/>
-        </p:nvSpPr>
-        <p:spPr>
-          <a:xfrm xmlns:a="http://schemas.openxmlformats.org/drawingml/2006/main">
-            <a:off x="6562725" y="2990850"/>
-            <a:ext cx="4857750" cy="1428750"/>
-          </a:xfrm>
-          <a:prstGeom xmlns:a="http://schemas.openxmlformats.org/drawingml/2006/main" prst="rect">
-            <a:avLst/>
-          </a:prstGeom>
-          <a:noFill xmlns:a="http://schemas.openxmlformats.org/drawingml/2006/main"/>
-          <a:ln xmlns:a="http://schemas.openxmlformats.org/drawingml/2006/main" w="0">
-            <a:noFill/>
-            <a:prstDash val="solid"/>
-          </a:ln>
-        </p:spPr>
-        <p:txBody>
-          <a:bodyPr xmlns:a="http://schemas.openxmlformats.org/drawingml/2006/main" wrap="square" lIns="0" tIns="0" rIns="0" bIns="0" anchor="t">
-            <a:normAutofit fontScale="94792"/>
-          </a:bodyPr>
-          <a:lstStyle xmlns:a="http://schemas.openxmlformats.org/drawingml/2006/main"/>
-          <a:p xmlns:a="http://schemas.openxmlformats.org/drawingml/2006/main">
-            <a:pPr marL="24" indent="-14" algn="l">
-              <a:lnSpc>
-                <a:spcPct val="115000"/>
-              </a:lnSpc>
-              <a:buNone/>
-              <a:defRPr sz="1350" b="0">
-                <a:solidFill>
-                  <a:srgbClr val="222222"/>
-                </a:solidFill>
-                <a:latin typeface="Helvetica Neue"/>
-                <a:ea typeface="Helvetica Neue"/>
-                <a:cs typeface="Helvetica Neue"/>
-              </a:defRPr>
-            </a:pPr>
-            <a:r>
-              <a:rPr sz="1350" b="0">
-                <a:solidFill>
-                  <a:srgbClr val="222222"/>
-                </a:solidFill>
-                <a:latin typeface="Helvetica Neue"/>
-                <a:ea typeface="Helvetica Neue"/>
-                <a:cs typeface="Helvetica Neue"/>
-              </a:rPr>
-              <a:t>Moins de temps perdu à reprendre la forme des données déjà disponibles.</a:t>
-            </a:r>
-          </a:p>
-          <a:p xmlns:a="http://schemas.openxmlformats.org/drawingml/2006/main">
-            <a:pPr marL="24" indent="-14" algn="l">
-              <a:lnSpc>
-                <a:spcPct val="115000"/>
-              </a:lnSpc>
-              <a:buNone/>
-              <a:defRPr sz="1350" b="0">
-                <a:solidFill>
-                  <a:srgbClr val="222222"/>
-                </a:solidFill>
-                <a:latin typeface="Helvetica Neue"/>
-                <a:ea typeface="Helvetica Neue"/>
-                <a:cs typeface="Helvetica Neue"/>
-              </a:defRPr>
-            </a:pPr>
-            <a:r>
-              <a:rPr sz="1350" b="0">
-                <a:solidFill>
-                  <a:srgbClr val="222222"/>
-                </a:solidFill>
-                <a:latin typeface="Helvetica Neue"/>
-                <a:ea typeface="Helvetica Neue"/>
-                <a:cs typeface="Helvetica Neue"/>
-              </a:rPr>
-              <a:t>Détection plus précoce des anomalies et des écarts importants.</a:t>
-            </a:r>
-          </a:p>
-          <a:p xmlns:a="http://schemas.openxmlformats.org/drawingml/2006/main">
-            <a:pPr marL="24" indent="-14" algn="l">
-              <a:lnSpc>
-                <a:spcPct val="115000"/>
-              </a:lnSpc>
-              <a:buNone/>
-              <a:defRPr sz="1350" b="0">
-                <a:solidFill>
-                  <a:srgbClr val="222222"/>
-                </a:solidFill>
-                <a:latin typeface="Helvetica Neue"/>
-                <a:ea typeface="Helvetica Neue"/>
-                <a:cs typeface="Helvetica Neue"/>
-              </a:defRPr>
-            </a:pPr>
-            <a:r>
-              <a:rPr sz="1350" b="0">
-                <a:solidFill>
-                  <a:srgbClr val="222222"/>
-                </a:solidFill>
-                <a:latin typeface="Helvetica Neue"/>
-                <a:ea typeface="Helvetica Neue"/>
-                <a:cs typeface="Helvetica Neue"/>
-              </a:rPr>
-              <a:t>Notes de synthèse plus homogènes entre comptabilité, contrôle et audit.</a:t>
-            </a:r>
-          </a:p>
-          <a:p xmlns:a="http://schemas.openxmlformats.org/drawingml/2006/main">
-            <a:pPr marL="24" indent="-14" algn="l">
-              <a:lnSpc>
-                <a:spcPct val="115000"/>
-              </a:lnSpc>
-              <a:buNone/>
-              <a:defRPr sz="1350" b="0">
-                <a:solidFill>
-                  <a:srgbClr val="222222"/>
-                </a:solidFill>
-                <a:latin typeface="Helvetica Neue"/>
-                <a:ea typeface="Helvetica Neue"/>
-                <a:cs typeface="Helvetica Neue"/>
-              </a:defRPr>
-            </a:pPr>
-            <a:r>
-              <a:rPr sz="1350" b="0">
-                <a:solidFill>
-                  <a:srgbClr val="222222"/>
-                </a:solidFill>
-                <a:latin typeface="Helvetica Neue"/>
-                <a:ea typeface="Helvetica Neue"/>
-                <a:cs typeface="Helvetica Neue"/>
-              </a:rPr>
-              <a:t>Meilleure préparation des comités et des arbitrages managériaux.</a:t>
-            </a:r>
-          </a:p>
-        </p:txBody>
-      </p:sp>
-      <p:sp>
-        <p:nvSpPr>
-          <p:cNvPr id="11" name="benefits-footer">
-            <a:extLst xmlns:a="http://schemas.openxmlformats.org/drawingml/2006/main">
-              <a:ext uri="{FF2B5EF4-FFF2-40B4-BE49-F238E27FC236}">
-                <a16:creationId xmlns:a16="http://schemas.microsoft.com/office/drawing/2014/main" id="{ED09CD28-7E34-413E-BC9A-981AC8657017}"/>
-              </a:ext>
-            </a:extLst>
-          </p:cNvPr>
-          <p:cNvSpPr>
-            <a:spLocks xmlns:a="http://schemas.openxmlformats.org/drawingml/2006/main" noGrp="1"/>
-          </p:cNvSpPr>
-          <p:nvPr/>
-        </p:nvSpPr>
-        <p:spPr>
-          <a:xfrm xmlns:a="http://schemas.openxmlformats.org/drawingml/2006/main">
-            <a:off x="400050" y="5334000"/>
-            <a:ext cx="11391900" cy="419100"/>
+              <a:t>2. Contrôles ciblés</a:t>
+            </a:r>
+          </a:p>
+        </p:txBody>
+      </p:sp>
+      <p:sp>
+        <p:nvSpPr>
+          <p:cNvPr id="10" name="workflow-body-350">
+            <a:extLst xmlns:a="http://schemas.openxmlformats.org/drawingml/2006/main">
+              <a:ext uri="{FF2B5EF4-FFF2-40B4-BE49-F238E27FC236}">
+                <a16:creationId xmlns:a16="http://schemas.microsoft.com/office/drawing/2014/main" id="{39ECA206-93B2-4C17-A422-C52ACAD8DC4F}"/>
+              </a:ext>
+            </a:extLst>
+          </p:cNvPr>
+          <p:cNvSpPr>
+            <a:spLocks xmlns:a="http://schemas.openxmlformats.org/drawingml/2006/main" noGrp="1"/>
+          </p:cNvSpPr>
+          <p:nvPr/>
+        </p:nvSpPr>
+        <p:spPr>
+          <a:xfrm xmlns:a="http://schemas.openxmlformats.org/drawingml/2006/main">
+            <a:off x="3562350" y="3124200"/>
+            <a:ext cx="2095500" cy="1257300"/>
           </a:xfrm>
           <a:prstGeom xmlns:a="http://schemas.openxmlformats.org/drawingml/2006/main" prst="rect">
             <a:avLst/>
@@ -4519,12 +4272,384 @@
           <a:p xmlns:a="http://schemas.openxmlformats.org/drawingml/2006/main">
             <a:pPr algn="l">
               <a:lnSpc>
+                <a:spcPct val="116000"/>
+              </a:lnSpc>
+              <a:buNone/>
+              <a:defRPr sz="1350" b="0">
+                <a:solidFill>
+                  <a:srgbClr val="222222"/>
+                </a:solidFill>
+                <a:latin typeface="Helvetica Neue"/>
+                <a:ea typeface="Helvetica Neue"/>
+                <a:cs typeface="Helvetica Neue"/>
+              </a:defRPr>
+            </a:pPr>
+            <a:r>
+              <a:rPr sz="1350" b="0">
+                <a:solidFill>
+                  <a:srgbClr val="222222"/>
+                </a:solidFill>
+                <a:latin typeface="Helvetica Neue"/>
+                <a:ea typeface="Helvetica Neue"/>
+                <a:cs typeface="Helvetica Neue"/>
+              </a:rPr>
+              <a:t>Les règles détectent les écarts, les seuils dépassés, les incohérences et les justificatifs manquants.</a:t>
+            </a:r>
+          </a:p>
+        </p:txBody>
+      </p:sp>
+      <p:sp>
+        <p:nvSpPr>
+          <p:cNvPr id="11" name="workflow-panel-658">
+            <a:extLst xmlns:a="http://schemas.openxmlformats.org/drawingml/2006/main">
+              <a:ext uri="{FF2B5EF4-FFF2-40B4-BE49-F238E27FC236}">
+                <a16:creationId xmlns:a16="http://schemas.microsoft.com/office/drawing/2014/main" id="{9532FA9B-5379-47EE-A4D5-9558AB13A05F}"/>
+              </a:ext>
+            </a:extLst>
+          </p:cNvPr>
+          <p:cNvSpPr>
+            <a:spLocks xmlns:a="http://schemas.openxmlformats.org/drawingml/2006/main" noGrp="1"/>
+          </p:cNvSpPr>
+          <p:nvPr/>
+        </p:nvSpPr>
+        <p:spPr>
+          <a:xfrm xmlns:a="http://schemas.openxmlformats.org/drawingml/2006/main">
+            <a:off x="6267450" y="1771650"/>
+            <a:ext cx="2590800" cy="3105150"/>
+          </a:xfrm>
+          <a:prstGeom xmlns:a="http://schemas.openxmlformats.org/drawingml/2006/main" prst="rect">
+            <a:avLst/>
+          </a:prstGeom>
+          <a:solidFill xmlns:a="http://schemas.openxmlformats.org/drawingml/2006/main">
+            <a:srgbClr val="EDEDED"/>
+          </a:solidFill>
+          <a:ln xmlns:a="http://schemas.openxmlformats.org/drawingml/2006/main" w="0">
+            <a:noFill/>
+            <a:prstDash val="solid"/>
+          </a:ln>
+        </p:spPr>
+      </p:sp>
+      <p:sp>
+        <p:nvSpPr>
+          <p:cNvPr id="12" name="workflow-step-658">
+            <a:extLst xmlns:a="http://schemas.openxmlformats.org/drawingml/2006/main">
+              <a:ext uri="{FF2B5EF4-FFF2-40B4-BE49-F238E27FC236}">
+                <a16:creationId xmlns:a16="http://schemas.microsoft.com/office/drawing/2014/main" id="{F55CC23A-CF5A-4064-8647-B4BE51B0A517}"/>
+              </a:ext>
+            </a:extLst>
+          </p:cNvPr>
+          <p:cNvSpPr>
+            <a:spLocks xmlns:a="http://schemas.openxmlformats.org/drawingml/2006/main" noGrp="1"/>
+          </p:cNvSpPr>
+          <p:nvPr/>
+        </p:nvSpPr>
+        <p:spPr>
+          <a:xfrm xmlns:a="http://schemas.openxmlformats.org/drawingml/2006/main">
+            <a:off x="6496050" y="2057400"/>
+            <a:ext cx="2095500" cy="571500"/>
+          </a:xfrm>
+          <a:prstGeom xmlns:a="http://schemas.openxmlformats.org/drawingml/2006/main" prst="rect">
+            <a:avLst/>
+          </a:prstGeom>
+          <a:noFill xmlns:a="http://schemas.openxmlformats.org/drawingml/2006/main"/>
+          <a:ln xmlns:a="http://schemas.openxmlformats.org/drawingml/2006/main" w="0">
+            <a:noFill/>
+            <a:prstDash val="solid"/>
+          </a:ln>
+        </p:spPr>
+        <p:txBody>
+          <a:bodyPr xmlns:a="http://schemas.openxmlformats.org/drawingml/2006/main" wrap="square" lIns="0" tIns="0" rIns="0" bIns="0" anchor="t">
+            <a:normAutofit fontScale="100000"/>
+          </a:bodyPr>
+          <a:lstStyle xmlns:a="http://schemas.openxmlformats.org/drawingml/2006/main"/>
+          <a:p xmlns:a="http://schemas.openxmlformats.org/drawingml/2006/main">
+            <a:pPr algn="l">
+              <a:lnSpc>
+                <a:spcPct val="102000"/>
+              </a:lnSpc>
+              <a:buNone/>
+              <a:defRPr sz="2025" b="0">
+                <a:solidFill>
+                  <a:srgbClr val="000000"/>
+                </a:solidFill>
+                <a:latin typeface="Helvetica Neue"/>
+                <a:ea typeface="Helvetica Neue"/>
+                <a:cs typeface="Helvetica Neue"/>
+              </a:defRPr>
+            </a:pPr>
+            <a:r>
+              <a:rPr sz="2025" b="0">
+                <a:solidFill>
+                  <a:srgbClr val="000000"/>
+                </a:solidFill>
+                <a:latin typeface="Helvetica Neue"/>
+                <a:ea typeface="Helvetica Neue"/>
+                <a:cs typeface="Helvetica Neue"/>
+              </a:rPr>
+              <a:t>3. Synthèse IA</a:t>
+            </a:r>
+          </a:p>
+        </p:txBody>
+      </p:sp>
+      <p:sp>
+        <p:nvSpPr>
+          <p:cNvPr id="13" name="workflow-body-658">
+            <a:extLst xmlns:a="http://schemas.openxmlformats.org/drawingml/2006/main">
+              <a:ext uri="{FF2B5EF4-FFF2-40B4-BE49-F238E27FC236}">
+                <a16:creationId xmlns:a16="http://schemas.microsoft.com/office/drawing/2014/main" id="{A98A770D-ED3D-4A45-A38E-D9BCCAFC1C12}"/>
+              </a:ext>
+            </a:extLst>
+          </p:cNvPr>
+          <p:cNvSpPr>
+            <a:spLocks xmlns:a="http://schemas.openxmlformats.org/drawingml/2006/main" noGrp="1"/>
+          </p:cNvSpPr>
+          <p:nvPr/>
+        </p:nvSpPr>
+        <p:spPr>
+          <a:xfrm xmlns:a="http://schemas.openxmlformats.org/drawingml/2006/main">
+            <a:off x="6496050" y="3124200"/>
+            <a:ext cx="2095500" cy="1257300"/>
+          </a:xfrm>
+          <a:prstGeom xmlns:a="http://schemas.openxmlformats.org/drawingml/2006/main" prst="rect">
+            <a:avLst/>
+          </a:prstGeom>
+          <a:noFill xmlns:a="http://schemas.openxmlformats.org/drawingml/2006/main"/>
+          <a:ln xmlns:a="http://schemas.openxmlformats.org/drawingml/2006/main" w="0">
+            <a:noFill/>
+            <a:prstDash val="solid"/>
+          </a:ln>
+        </p:spPr>
+        <p:txBody>
+          <a:bodyPr xmlns:a="http://schemas.openxmlformats.org/drawingml/2006/main" wrap="square" lIns="0" tIns="0" rIns="0" bIns="0" anchor="t">
+            <a:normAutofit fontScale="100000"/>
+          </a:bodyPr>
+          <a:lstStyle xmlns:a="http://schemas.openxmlformats.org/drawingml/2006/main"/>
+          <a:p xmlns:a="http://schemas.openxmlformats.org/drawingml/2006/main">
+            <a:pPr algn="l">
+              <a:lnSpc>
+                <a:spcPct val="116000"/>
+              </a:lnSpc>
+              <a:buNone/>
+              <a:defRPr sz="1350" b="0">
+                <a:solidFill>
+                  <a:srgbClr val="222222"/>
+                </a:solidFill>
+                <a:latin typeface="Helvetica Neue"/>
+                <a:ea typeface="Helvetica Neue"/>
+                <a:cs typeface="Helvetica Neue"/>
+              </a:defRPr>
+            </a:pPr>
+            <a:r>
+              <a:rPr sz="1350" b="0">
+                <a:solidFill>
+                  <a:srgbClr val="222222"/>
+                </a:solidFill>
+                <a:latin typeface="Helvetica Neue"/>
+                <a:ea typeface="Helvetica Neue"/>
+                <a:cs typeface="Helvetica Neue"/>
+              </a:rPr>
+              <a:t>L’IA rédige un commentaire clair en français professionnel pour accélérer la lecture managériale.</a:t>
+            </a:r>
+          </a:p>
+        </p:txBody>
+      </p:sp>
+      <p:sp>
+        <p:nvSpPr>
+          <p:cNvPr id="14" name="workflow-panel-966">
+            <a:extLst xmlns:a="http://schemas.openxmlformats.org/drawingml/2006/main">
+              <a:ext uri="{FF2B5EF4-FFF2-40B4-BE49-F238E27FC236}">
+                <a16:creationId xmlns:a16="http://schemas.microsoft.com/office/drawing/2014/main" id="{57F36017-32FC-4DFB-B737-FBD724FC19C2}"/>
+              </a:ext>
+            </a:extLst>
+          </p:cNvPr>
+          <p:cNvSpPr>
+            <a:spLocks xmlns:a="http://schemas.openxmlformats.org/drawingml/2006/main" noGrp="1"/>
+          </p:cNvSpPr>
+          <p:nvPr/>
+        </p:nvSpPr>
+        <p:spPr>
+          <a:xfrm xmlns:a="http://schemas.openxmlformats.org/drawingml/2006/main">
+            <a:off x="9201150" y="1771650"/>
+            <a:ext cx="2590800" cy="3105150"/>
+          </a:xfrm>
+          <a:prstGeom xmlns:a="http://schemas.openxmlformats.org/drawingml/2006/main" prst="rect">
+            <a:avLst/>
+          </a:prstGeom>
+          <a:solidFill xmlns:a="http://schemas.openxmlformats.org/drawingml/2006/main">
+            <a:srgbClr val="EDEDED"/>
+          </a:solidFill>
+          <a:ln xmlns:a="http://schemas.openxmlformats.org/drawingml/2006/main" w="0">
+            <a:noFill/>
+            <a:prstDash val="solid"/>
+          </a:ln>
+        </p:spPr>
+      </p:sp>
+      <p:sp>
+        <p:nvSpPr>
+          <p:cNvPr id="15" name="workflow-step-966">
+            <a:extLst xmlns:a="http://schemas.openxmlformats.org/drawingml/2006/main">
+              <a:ext uri="{FF2B5EF4-FFF2-40B4-BE49-F238E27FC236}">
+                <a16:creationId xmlns:a16="http://schemas.microsoft.com/office/drawing/2014/main" id="{2EE42E4D-50A1-45C0-A31C-DC3E9D0B69A9}"/>
+              </a:ext>
+            </a:extLst>
+          </p:cNvPr>
+          <p:cNvSpPr>
+            <a:spLocks xmlns:a="http://schemas.openxmlformats.org/drawingml/2006/main" noGrp="1"/>
+          </p:cNvSpPr>
+          <p:nvPr/>
+        </p:nvSpPr>
+        <p:spPr>
+          <a:xfrm xmlns:a="http://schemas.openxmlformats.org/drawingml/2006/main">
+            <a:off x="9429750" y="2057400"/>
+            <a:ext cx="2095500" cy="571500"/>
+          </a:xfrm>
+          <a:prstGeom xmlns:a="http://schemas.openxmlformats.org/drawingml/2006/main" prst="rect">
+            <a:avLst/>
+          </a:prstGeom>
+          <a:noFill xmlns:a="http://schemas.openxmlformats.org/drawingml/2006/main"/>
+          <a:ln xmlns:a="http://schemas.openxmlformats.org/drawingml/2006/main" w="0">
+            <a:noFill/>
+            <a:prstDash val="solid"/>
+          </a:ln>
+        </p:spPr>
+        <p:txBody>
+          <a:bodyPr xmlns:a="http://schemas.openxmlformats.org/drawingml/2006/main" wrap="square" lIns="0" tIns="0" rIns="0" bIns="0" anchor="t">
+            <a:normAutofit fontScale="90777"/>
+          </a:bodyPr>
+          <a:lstStyle xmlns:a="http://schemas.openxmlformats.org/drawingml/2006/main"/>
+          <a:p xmlns:a="http://schemas.openxmlformats.org/drawingml/2006/main">
+            <a:pPr algn="l">
+              <a:lnSpc>
+                <a:spcPct val="102000"/>
+              </a:lnSpc>
+              <a:buNone/>
+              <a:defRPr sz="2025" b="0">
+                <a:solidFill>
+                  <a:srgbClr val="000000"/>
+                </a:solidFill>
+                <a:latin typeface="Helvetica Neue"/>
+                <a:ea typeface="Helvetica Neue"/>
+                <a:cs typeface="Helvetica Neue"/>
+              </a:defRPr>
+            </a:pPr>
+            <a:r>
+              <a:rPr sz="2025" b="0">
+                <a:solidFill>
+                  <a:srgbClr val="000000"/>
+                </a:solidFill>
+                <a:latin typeface="Helvetica Neue"/>
+                <a:ea typeface="Helvetica Neue"/>
+                <a:cs typeface="Helvetica Neue"/>
+              </a:rPr>
+              <a:t>4. Validation et diffusion</a:t>
+            </a:r>
+          </a:p>
+        </p:txBody>
+      </p:sp>
+      <p:sp>
+        <p:nvSpPr>
+          <p:cNvPr id="16" name="workflow-body-966">
+            <a:extLst xmlns:a="http://schemas.openxmlformats.org/drawingml/2006/main">
+              <a:ext uri="{FF2B5EF4-FFF2-40B4-BE49-F238E27FC236}">
+                <a16:creationId xmlns:a16="http://schemas.microsoft.com/office/drawing/2014/main" id="{44B59586-4410-4B2A-A4B2-53C4E4006163}"/>
+              </a:ext>
+            </a:extLst>
+          </p:cNvPr>
+          <p:cNvSpPr>
+            <a:spLocks xmlns:a="http://schemas.openxmlformats.org/drawingml/2006/main" noGrp="1"/>
+          </p:cNvSpPr>
+          <p:nvPr/>
+        </p:nvSpPr>
+        <p:spPr>
+          <a:xfrm xmlns:a="http://schemas.openxmlformats.org/drawingml/2006/main">
+            <a:off x="9429750" y="3124200"/>
+            <a:ext cx="2095500" cy="1257300"/>
+          </a:xfrm>
+          <a:prstGeom xmlns:a="http://schemas.openxmlformats.org/drawingml/2006/main" prst="rect">
+            <a:avLst/>
+          </a:prstGeom>
+          <a:noFill xmlns:a="http://schemas.openxmlformats.org/drawingml/2006/main"/>
+          <a:ln xmlns:a="http://schemas.openxmlformats.org/drawingml/2006/main" w="0">
+            <a:noFill/>
+            <a:prstDash val="solid"/>
+          </a:ln>
+        </p:spPr>
+        <p:txBody>
+          <a:bodyPr xmlns:a="http://schemas.openxmlformats.org/drawingml/2006/main" wrap="square" lIns="0" tIns="0" rIns="0" bIns="0" anchor="t">
+            <a:normAutofit fontScale="100000"/>
+          </a:bodyPr>
+          <a:lstStyle xmlns:a="http://schemas.openxmlformats.org/drawingml/2006/main"/>
+          <a:p xmlns:a="http://schemas.openxmlformats.org/drawingml/2006/main">
+            <a:pPr algn="l">
+              <a:lnSpc>
+                <a:spcPct val="116000"/>
+              </a:lnSpc>
+              <a:buNone/>
+              <a:defRPr sz="1350" b="0">
+                <a:solidFill>
+                  <a:srgbClr val="222222"/>
+                </a:solidFill>
+                <a:latin typeface="Helvetica Neue"/>
+                <a:ea typeface="Helvetica Neue"/>
+                <a:cs typeface="Helvetica Neue"/>
+              </a:defRPr>
+            </a:pPr>
+            <a:r>
+              <a:rPr sz="1350" b="0">
+                <a:solidFill>
+                  <a:srgbClr val="222222"/>
+                </a:solidFill>
+                <a:latin typeface="Helvetica Neue"/>
+                <a:ea typeface="Helvetica Neue"/>
+                <a:cs typeface="Helvetica Neue"/>
+              </a:rPr>
+              <a:t>Un responsable relit, valide puis transmet la version finale au contrôle financier, à la comptabilité ou au comité.</a:t>
+            </a:r>
+          </a:p>
+        </p:txBody>
+      </p:sp>
+      <p:sp>
+        <p:nvSpPr>
+          <p:cNvPr id="17" name="workflow-footer">
+            <a:extLst xmlns:a="http://schemas.openxmlformats.org/drawingml/2006/main">
+              <a:ext uri="{FF2B5EF4-FFF2-40B4-BE49-F238E27FC236}">
+                <a16:creationId xmlns:a16="http://schemas.microsoft.com/office/drawing/2014/main" id="{4846E6DB-CCFF-4FF9-A3A2-D88C9F8CA5DA}"/>
+              </a:ext>
+            </a:extLst>
+          </p:cNvPr>
+          <p:cNvSpPr>
+            <a:spLocks xmlns:a="http://schemas.openxmlformats.org/drawingml/2006/main" noGrp="1"/>
+          </p:cNvSpPr>
+          <p:nvPr/>
+        </p:nvSpPr>
+        <p:spPr>
+          <a:xfrm xmlns:a="http://schemas.openxmlformats.org/drawingml/2006/main">
+            <a:off x="400050" y="5381625"/>
+            <a:ext cx="11334750" cy="323850"/>
+          </a:xfrm>
+          <a:prstGeom xmlns:a="http://schemas.openxmlformats.org/drawingml/2006/main" prst="rect">
+            <a:avLst/>
+          </a:prstGeom>
+          <a:noFill xmlns:a="http://schemas.openxmlformats.org/drawingml/2006/main"/>
+          <a:ln xmlns:a="http://schemas.openxmlformats.org/drawingml/2006/main" w="0">
+            <a:noFill/>
+            <a:prstDash val="solid"/>
+          </a:ln>
+        </p:spPr>
+        <p:txBody>
+          <a:bodyPr xmlns:a="http://schemas.openxmlformats.org/drawingml/2006/main" wrap="square" lIns="0" tIns="0" rIns="0" bIns="0" anchor="t">
+            <a:normAutofit fontScale="100000"/>
+          </a:bodyPr>
+          <a:lstStyle xmlns:a="http://schemas.openxmlformats.org/drawingml/2006/main"/>
+          <a:p xmlns:a="http://schemas.openxmlformats.org/drawingml/2006/main">
+            <a:pPr algn="l">
+              <a:lnSpc>
                 <a:spcPct val="108000"/>
               </a:lnSpc>
               <a:buNone/>
               <a:defRPr sz="1650" b="0">
                 <a:solidFill>
-                  <a:srgbClr val="000000"/>
+                  <a:srgbClr val="222222"/>
                 </a:solidFill>
                 <a:latin typeface="Helvetica Neue"/>
                 <a:ea typeface="Helvetica Neue"/>
@@ -4534,23 +4659,23 @@
             <a:r>
               <a:rPr sz="1650" b="0">
                 <a:solidFill>
-                  <a:srgbClr val="000000"/>
-                </a:solidFill>
-                <a:latin typeface="Helvetica Neue"/>
-                <a:ea typeface="Helvetica Neue"/>
-                <a:cs typeface="Helvetica Neue"/>
-              </a:rPr>
-              <a:t>Contrôle humain maintenu sur tous les usages sensibles et sur toute diffusion officielle.</a:t>
-            </a:r>
-          </a:p>
-        </p:txBody>
-      </p:sp>
-      <p:sp>
-        <p:nvSpPr>
-          <p:cNvPr id="12" name="footer-04">
-            <a:extLst xmlns:a="http://schemas.openxmlformats.org/drawingml/2006/main">
-              <a:ext uri="{FF2B5EF4-FFF2-40B4-BE49-F238E27FC236}">
-                <a16:creationId xmlns:a16="http://schemas.microsoft.com/office/drawing/2014/main" id="{378BD9D6-49EE-4886-A7B8-C78A2843B183}"/>
+                  <a:srgbClr val="222222"/>
+                </a:solidFill>
+                <a:latin typeface="Helvetica Neue"/>
+                <a:ea typeface="Helvetica Neue"/>
+                <a:cs typeface="Helvetica Neue"/>
+              </a:rPr>
+              <a:t>La diffusion automatique n’intervient qu’après validation humaine.</a:t>
+            </a:r>
+          </a:p>
+        </p:txBody>
+      </p:sp>
+      <p:sp>
+        <p:nvSpPr>
+          <p:cNvPr id="18" name="footer-03">
+            <a:extLst xmlns:a="http://schemas.openxmlformats.org/drawingml/2006/main">
+              <a:ext uri="{FF2B5EF4-FFF2-40B4-BE49-F238E27FC236}">
+                <a16:creationId xmlns:a16="http://schemas.microsoft.com/office/drawing/2014/main" id="{C34B5965-316A-4958-B9FD-C0338B72AFF4}"/>
               </a:ext>
             </a:extLst>
           </p:cNvPr>
@@ -4610,7 +4735,7 @@
     </p:spTree>
     <p:extLst>
       <p:ext uri="{BB962C8B-B14F-4D97-AF65-F5344CB8AC3E}">
-        <p14:creationId xmlns:p14="http://schemas.microsoft.com/office/powerpoint/2010/main" val="225802777"/>
+        <p14:creationId xmlns:p14="http://schemas.microsoft.com/office/powerpoint/2010/main" val="454270334"/>
       </p:ext>
     </p:extLst>
   </p:cSld>
@@ -4638,10 +4763,10 @@
       </p:grpSpPr>
       <p:sp>
         <p:nvSpPr>
-          <p:cNvPr id="1" name="section-Pilotage">
-            <a:extLst xmlns:a="http://schemas.openxmlformats.org/drawingml/2006/main">
-              <a:ext uri="{FF2B5EF4-FFF2-40B4-BE49-F238E27FC236}">
-                <a16:creationId xmlns:a16="http://schemas.microsoft.com/office/drawing/2014/main" id="{5AC7B388-201F-4CD8-BC20-D93B6E28C49C}"/>
+          <p:cNvPr id="1" name="section-Bénéfices">
+            <a:extLst xmlns:a="http://schemas.openxmlformats.org/drawingml/2006/main">
+              <a:ext uri="{FF2B5EF4-FFF2-40B4-BE49-F238E27FC236}">
+                <a16:creationId xmlns:a16="http://schemas.microsoft.com/office/drawing/2014/main" id="{0707F894-E914-4C20-A24C-F2F898213CE9}"/>
               </a:ext>
             </a:extLst>
           </p:cNvPr>
@@ -4693,21 +4818,21 @@
                 <a:ea typeface="Helvetica Neue"/>
                 <a:cs typeface="Helvetica Neue"/>
               </a:rPr>
-              <a:t>Pilotage</a:t>
+              <a:t>Bénéfices</a:t>
             </a:r>
           </a:p>
         </p:txBody>
       </p:sp>
       <p:pic>
         <p:nvPicPr>
-          <p:cNvPr id="26" name=""/>
+          <p:cNvPr id="15" name=""/>
           <p:cNvPicPr>
             <a:picLocks xmlns:a="http://schemas.openxmlformats.org/drawingml/2006/main" noChangeAspect="1"/>
           </p:cNvPicPr>
           <p:nvPr/>
         </p:nvPicPr>
         <p:blipFill>
-          <a:blip xmlns:r="http://schemas.openxmlformats.org/officeDocument/2006/relationships" xmlns:a="http://schemas.openxmlformats.org/drawingml/2006/main" r:embed="Rf07d4666c30548b3"/>
+          <a:blip xmlns:r="http://schemas.openxmlformats.org/officeDocument/2006/relationships" xmlns:a="http://schemas.openxmlformats.org/drawingml/2006/main" r:embed="R84f5ed2047144820"/>
           <a:stretch xmlns:a="http://schemas.openxmlformats.org/drawingml/2006/main"/>
         </p:blipFill>
         <p:spPr>
@@ -4722,10 +4847,10 @@
       </p:pic>
       <p:sp>
         <p:nvSpPr>
-          <p:cNvPr id="3" name="kpi-title">
-            <a:extLst xmlns:a="http://schemas.openxmlformats.org/drawingml/2006/main">
-              <a:ext uri="{FF2B5EF4-FFF2-40B4-BE49-F238E27FC236}">
-                <a16:creationId xmlns:a16="http://schemas.microsoft.com/office/drawing/2014/main" id="{9A7C8067-8DEF-44DC-A61A-ECE74F2A5D95}"/>
+          <p:cNvPr id="3" name="benefits-title">
+            <a:extLst xmlns:a="http://schemas.openxmlformats.org/drawingml/2006/main">
+              <a:ext uri="{FF2B5EF4-FFF2-40B4-BE49-F238E27FC236}">
+                <a16:creationId xmlns:a16="http://schemas.microsoft.com/office/drawing/2014/main" id="{17616589-F9F5-4016-94B5-2E54D153B706}"/>
               </a:ext>
             </a:extLst>
           </p:cNvPr>
@@ -4737,7 +4862,603 @@
         <p:spPr>
           <a:xfrm xmlns:a="http://schemas.openxmlformats.org/drawingml/2006/main">
             <a:off x="400050" y="342900"/>
+            <a:ext cx="10668000" cy="742950"/>
+          </a:xfrm>
+          <a:prstGeom xmlns:a="http://schemas.openxmlformats.org/drawingml/2006/main" prst="rect">
+            <a:avLst/>
+          </a:prstGeom>
+          <a:noFill xmlns:a="http://schemas.openxmlformats.org/drawingml/2006/main"/>
+          <a:ln xmlns:a="http://schemas.openxmlformats.org/drawingml/2006/main" w="0">
+            <a:noFill/>
+            <a:prstDash val="solid"/>
+          </a:ln>
+        </p:spPr>
+        <p:txBody>
+          <a:bodyPr xmlns:a="http://schemas.openxmlformats.org/drawingml/2006/main" wrap="square" lIns="0" tIns="0" rIns="0" bIns="0" anchor="t">
+            <a:normAutofit fontScale="83333"/>
+          </a:bodyPr>
+          <a:lstStyle xmlns:a="http://schemas.openxmlformats.org/drawingml/2006/main"/>
+          <a:p xmlns:a="http://schemas.openxmlformats.org/drawingml/2006/main">
+            <a:pPr algn="l">
+              <a:lnSpc>
+                <a:spcPct val="100000"/>
+              </a:lnSpc>
+              <a:buNone/>
+              <a:defRPr sz="2925" b="0">
+                <a:solidFill>
+                  <a:srgbClr val="000000"/>
+                </a:solidFill>
+                <a:latin typeface="Helvetica Neue"/>
+                <a:ea typeface="Helvetica Neue"/>
+                <a:cs typeface="Helvetica Neue"/>
+              </a:defRPr>
+            </a:pPr>
+            <a:r>
+              <a:rPr sz="2925" b="0">
+                <a:solidFill>
+                  <a:srgbClr val="000000"/>
+                </a:solidFill>
+                <a:latin typeface="Helvetica Neue"/>
+                <a:ea typeface="Helvetica Neue"/>
+                <a:cs typeface="Helvetica Neue"/>
+              </a:rPr>
+              <a:t>Le gain vient d’abord de la vitesse, de l’homogénéité et d’une revue plus précoce</a:t>
+            </a:r>
+          </a:p>
+        </p:txBody>
+      </p:sp>
+      <p:sp>
+        <p:nvSpPr>
+          <p:cNvPr id="4" name="benefits-intro">
+            <a:extLst xmlns:a="http://schemas.openxmlformats.org/drawingml/2006/main">
+              <a:ext uri="{FF2B5EF4-FFF2-40B4-BE49-F238E27FC236}">
+                <a16:creationId xmlns:a16="http://schemas.microsoft.com/office/drawing/2014/main" id="{5E032665-3E00-4651-96A3-87E7EBCA645D}"/>
+              </a:ext>
+            </a:extLst>
+          </p:cNvPr>
+          <p:cNvSpPr>
+            <a:spLocks xmlns:a="http://schemas.openxmlformats.org/drawingml/2006/main" noGrp="1"/>
+          </p:cNvSpPr>
+          <p:nvPr/>
+        </p:nvSpPr>
+        <p:spPr>
+          <a:xfrm xmlns:a="http://schemas.openxmlformats.org/drawingml/2006/main">
+            <a:off x="400050" y="1181100"/>
             <a:ext cx="10668000" cy="552450"/>
+          </a:xfrm>
+          <a:prstGeom xmlns:a="http://schemas.openxmlformats.org/drawingml/2006/main" prst="rect">
+            <a:avLst/>
+          </a:prstGeom>
+          <a:noFill xmlns:a="http://schemas.openxmlformats.org/drawingml/2006/main"/>
+          <a:ln xmlns:a="http://schemas.openxmlformats.org/drawingml/2006/main" w="0">
+            <a:noFill/>
+            <a:prstDash val="solid"/>
+          </a:ln>
+        </p:spPr>
+        <p:txBody>
+          <a:bodyPr xmlns:a="http://schemas.openxmlformats.org/drawingml/2006/main" wrap="square" lIns="0" tIns="0" rIns="0" bIns="0" anchor="t">
+            <a:normAutofit fontScale="97525"/>
+          </a:bodyPr>
+          <a:lstStyle xmlns:a="http://schemas.openxmlformats.org/drawingml/2006/main"/>
+          <a:p xmlns:a="http://schemas.openxmlformats.org/drawingml/2006/main">
+            <a:pPr algn="l">
+              <a:lnSpc>
+                <a:spcPct val="118000"/>
+              </a:lnSpc>
+              <a:buNone/>
+              <a:defRPr sz="1575" b="0">
+                <a:solidFill>
+                  <a:srgbClr val="222222"/>
+                </a:solidFill>
+                <a:latin typeface="Helvetica Neue"/>
+                <a:ea typeface="Helvetica Neue"/>
+                <a:cs typeface="Helvetica Neue"/>
+              </a:defRPr>
+            </a:pPr>
+            <a:r>
+              <a:rPr sz="1575" b="0">
+                <a:solidFill>
+                  <a:srgbClr val="222222"/>
+                </a:solidFill>
+                <a:latin typeface="Helvetica Neue"/>
+                <a:ea typeface="Helvetica Neue"/>
+                <a:cs typeface="Helvetica Neue"/>
+              </a:rPr>
+              <a:t>Le cas d’usage n’essaie pas de remplacer le jugement financier. Il réduit les tâches de reprise, améliore la lisibilité des écarts et prépare mieux les arbitrages.</a:t>
+            </a:r>
+          </a:p>
+        </p:txBody>
+      </p:sp>
+      <p:sp>
+        <p:nvSpPr>
+          <p:cNvPr id="5" name="before-panel">
+            <a:extLst xmlns:a="http://schemas.openxmlformats.org/drawingml/2006/main">
+              <a:ext uri="{FF2B5EF4-FFF2-40B4-BE49-F238E27FC236}">
+                <a16:creationId xmlns:a16="http://schemas.microsoft.com/office/drawing/2014/main" id="{BF31BA90-495C-41E6-B08A-40A64C5589D9}"/>
+              </a:ext>
+            </a:extLst>
+          </p:cNvPr>
+          <p:cNvSpPr>
+            <a:spLocks xmlns:a="http://schemas.openxmlformats.org/drawingml/2006/main" noGrp="1"/>
+          </p:cNvSpPr>
+          <p:nvPr/>
+        </p:nvSpPr>
+        <p:spPr>
+          <a:xfrm xmlns:a="http://schemas.openxmlformats.org/drawingml/2006/main">
+            <a:off x="400050" y="2190750"/>
+            <a:ext cx="5534025" cy="2647950"/>
+          </a:xfrm>
+          <a:prstGeom xmlns:a="http://schemas.openxmlformats.org/drawingml/2006/main" prst="rect">
+            <a:avLst/>
+          </a:prstGeom>
+          <a:solidFill xmlns:a="http://schemas.openxmlformats.org/drawingml/2006/main">
+            <a:srgbClr val="EDEDED"/>
+          </a:solidFill>
+          <a:ln xmlns:a="http://schemas.openxmlformats.org/drawingml/2006/main" w="0">
+            <a:noFill/>
+            <a:prstDash val="solid"/>
+          </a:ln>
+        </p:spPr>
+      </p:sp>
+      <p:sp>
+        <p:nvSpPr>
+          <p:cNvPr id="6" name="before-title">
+            <a:extLst xmlns:a="http://schemas.openxmlformats.org/drawingml/2006/main">
+              <a:ext uri="{FF2B5EF4-FFF2-40B4-BE49-F238E27FC236}">
+                <a16:creationId xmlns:a16="http://schemas.microsoft.com/office/drawing/2014/main" id="{1D30D9EF-DECC-4CF7-B51A-58DB08F0D97C}"/>
+              </a:ext>
+            </a:extLst>
+          </p:cNvPr>
+          <p:cNvSpPr>
+            <a:spLocks xmlns:a="http://schemas.openxmlformats.org/drawingml/2006/main" noGrp="1"/>
+          </p:cNvSpPr>
+          <p:nvPr/>
+        </p:nvSpPr>
+        <p:spPr>
+          <a:xfrm xmlns:a="http://schemas.openxmlformats.org/drawingml/2006/main">
+            <a:off x="695325" y="2457450"/>
+            <a:ext cx="1238250" cy="323850"/>
+          </a:xfrm>
+          <a:prstGeom xmlns:a="http://schemas.openxmlformats.org/drawingml/2006/main" prst="rect">
+            <a:avLst/>
+          </a:prstGeom>
+          <a:noFill xmlns:a="http://schemas.openxmlformats.org/drawingml/2006/main"/>
+          <a:ln xmlns:a="http://schemas.openxmlformats.org/drawingml/2006/main" w="0">
+            <a:noFill/>
+            <a:prstDash val="solid"/>
+          </a:ln>
+        </p:spPr>
+        <p:txBody>
+          <a:bodyPr xmlns:a="http://schemas.openxmlformats.org/drawingml/2006/main" wrap="square" lIns="0" tIns="0" rIns="0" bIns="0" anchor="t">
+            <a:normAutofit fontScale="87449"/>
+          </a:bodyPr>
+          <a:lstStyle xmlns:a="http://schemas.openxmlformats.org/drawingml/2006/main"/>
+          <a:p xmlns:a="http://schemas.openxmlformats.org/drawingml/2006/main">
+            <a:pPr algn="l">
+              <a:lnSpc>
+                <a:spcPct val="108000"/>
+              </a:lnSpc>
+              <a:buNone/>
+              <a:defRPr sz="2250" b="0">
+                <a:solidFill>
+                  <a:srgbClr val="000000"/>
+                </a:solidFill>
+                <a:latin typeface="Helvetica Neue"/>
+                <a:ea typeface="Helvetica Neue"/>
+                <a:cs typeface="Helvetica Neue"/>
+              </a:defRPr>
+            </a:pPr>
+            <a:r>
+              <a:rPr sz="2250" b="0">
+                <a:solidFill>
+                  <a:srgbClr val="000000"/>
+                </a:solidFill>
+                <a:latin typeface="Helvetica Neue"/>
+                <a:ea typeface="Helvetica Neue"/>
+                <a:cs typeface="Helvetica Neue"/>
+              </a:rPr>
+              <a:t>Avant</a:t>
+            </a:r>
+          </a:p>
+        </p:txBody>
+      </p:sp>
+      <p:sp>
+        <p:nvSpPr>
+          <p:cNvPr id="7" name="before-bullets">
+            <a:extLst xmlns:a="http://schemas.openxmlformats.org/drawingml/2006/main">
+              <a:ext uri="{FF2B5EF4-FFF2-40B4-BE49-F238E27FC236}">
+                <a16:creationId xmlns:a16="http://schemas.microsoft.com/office/drawing/2014/main" id="{3ED9379E-BDA5-40B6-851D-D72A7F812CAA}"/>
+              </a:ext>
+            </a:extLst>
+          </p:cNvPr>
+          <p:cNvSpPr>
+            <a:spLocks xmlns:a="http://schemas.openxmlformats.org/drawingml/2006/main" noGrp="1"/>
+          </p:cNvSpPr>
+          <p:nvPr/>
+        </p:nvSpPr>
+        <p:spPr>
+          <a:xfrm xmlns:a="http://schemas.openxmlformats.org/drawingml/2006/main">
+            <a:off x="695325" y="2990850"/>
+            <a:ext cx="4857750" cy="1428750"/>
+          </a:xfrm>
+          <a:prstGeom xmlns:a="http://schemas.openxmlformats.org/drawingml/2006/main" prst="rect">
+            <a:avLst/>
+          </a:prstGeom>
+          <a:noFill xmlns:a="http://schemas.openxmlformats.org/drawingml/2006/main"/>
+          <a:ln xmlns:a="http://schemas.openxmlformats.org/drawingml/2006/main" w="0">
+            <a:noFill/>
+            <a:prstDash val="solid"/>
+          </a:ln>
+        </p:spPr>
+        <p:txBody>
+          <a:bodyPr xmlns:a="http://schemas.openxmlformats.org/drawingml/2006/main" wrap="square" lIns="0" tIns="0" rIns="0" bIns="0" anchor="t">
+            <a:normAutofit fontScale="99925"/>
+          </a:bodyPr>
+          <a:lstStyle xmlns:a="http://schemas.openxmlformats.org/drawingml/2006/main"/>
+          <a:p xmlns:a="http://schemas.openxmlformats.org/drawingml/2006/main">
+            <a:pPr marL="24" indent="-14" algn="l">
+              <a:lnSpc>
+                <a:spcPct val="115000"/>
+              </a:lnSpc>
+              <a:buNone/>
+              <a:defRPr sz="1350" b="0">
+                <a:solidFill>
+                  <a:srgbClr val="222222"/>
+                </a:solidFill>
+                <a:latin typeface="Helvetica Neue"/>
+                <a:ea typeface="Helvetica Neue"/>
+                <a:cs typeface="Helvetica Neue"/>
+              </a:defRPr>
+            </a:pPr>
+            <a:r>
+              <a:rPr sz="1350" b="0">
+                <a:solidFill>
+                  <a:srgbClr val="222222"/>
+                </a:solidFill>
+                <a:latin typeface="Helvetica Neue"/>
+                <a:ea typeface="Helvetica Neue"/>
+                <a:cs typeface="Helvetica Neue"/>
+              </a:rPr>
+              <a:t>Beaucoup de temps passé à reformater et commenter les chiffres.</a:t>
+            </a:r>
+          </a:p>
+          <a:p xmlns:a="http://schemas.openxmlformats.org/drawingml/2006/main">
+            <a:pPr marL="24" indent="-14" algn="l">
+              <a:lnSpc>
+                <a:spcPct val="115000"/>
+              </a:lnSpc>
+              <a:buNone/>
+              <a:defRPr sz="1350" b="0">
+                <a:solidFill>
+                  <a:srgbClr val="222222"/>
+                </a:solidFill>
+                <a:latin typeface="Helvetica Neue"/>
+                <a:ea typeface="Helvetica Neue"/>
+                <a:cs typeface="Helvetica Neue"/>
+              </a:defRPr>
+            </a:pPr>
+            <a:r>
+              <a:rPr sz="1350" b="0">
+                <a:solidFill>
+                  <a:srgbClr val="222222"/>
+                </a:solidFill>
+                <a:latin typeface="Helvetica Neue"/>
+                <a:ea typeface="Helvetica Neue"/>
+                <a:cs typeface="Helvetica Neue"/>
+              </a:rPr>
+              <a:t>Détection plus tardive des anomalies et des justificatifs manquants.</a:t>
+            </a:r>
+          </a:p>
+          <a:p xmlns:a="http://schemas.openxmlformats.org/drawingml/2006/main">
+            <a:pPr marL="24" indent="-14" algn="l">
+              <a:lnSpc>
+                <a:spcPct val="115000"/>
+              </a:lnSpc>
+              <a:buNone/>
+              <a:defRPr sz="1350" b="0">
+                <a:solidFill>
+                  <a:srgbClr val="222222"/>
+                </a:solidFill>
+                <a:latin typeface="Helvetica Neue"/>
+                <a:ea typeface="Helvetica Neue"/>
+                <a:cs typeface="Helvetica Neue"/>
+              </a:defRPr>
+            </a:pPr>
+            <a:r>
+              <a:rPr sz="1350" b="0">
+                <a:solidFill>
+                  <a:srgbClr val="222222"/>
+                </a:solidFill>
+                <a:latin typeface="Helvetica Neue"/>
+                <a:ea typeface="Helvetica Neue"/>
+                <a:cs typeface="Helvetica Neue"/>
+              </a:rPr>
+              <a:t>Notes de synthèse variables selon les équipes et les périodes.</a:t>
+            </a:r>
+          </a:p>
+          <a:p xmlns:a="http://schemas.openxmlformats.org/drawingml/2006/main">
+            <a:pPr marL="24" indent="-14" algn="l">
+              <a:lnSpc>
+                <a:spcPct val="115000"/>
+              </a:lnSpc>
+              <a:buNone/>
+              <a:defRPr sz="1350" b="0">
+                <a:solidFill>
+                  <a:srgbClr val="222222"/>
+                </a:solidFill>
+                <a:latin typeface="Helvetica Neue"/>
+                <a:ea typeface="Helvetica Neue"/>
+                <a:cs typeface="Helvetica Neue"/>
+              </a:defRPr>
+            </a:pPr>
+            <a:r>
+              <a:rPr sz="1350" b="0">
+                <a:solidFill>
+                  <a:srgbClr val="222222"/>
+                </a:solidFill>
+                <a:latin typeface="Helvetica Neue"/>
+                <a:ea typeface="Helvetica Neue"/>
+                <a:cs typeface="Helvetica Neue"/>
+              </a:rPr>
+              <a:t>Information parfois trop brute ou trop tardive pour le comité.</a:t>
+            </a:r>
+          </a:p>
+        </p:txBody>
+      </p:sp>
+      <p:sp>
+        <p:nvSpPr>
+          <p:cNvPr id="8" name="after-panel">
+            <a:extLst xmlns:a="http://schemas.openxmlformats.org/drawingml/2006/main">
+              <a:ext uri="{FF2B5EF4-FFF2-40B4-BE49-F238E27FC236}">
+                <a16:creationId xmlns:a16="http://schemas.microsoft.com/office/drawing/2014/main" id="{86952376-4616-441B-A70A-C1B96177CF74}"/>
+              </a:ext>
+            </a:extLst>
+          </p:cNvPr>
+          <p:cNvSpPr>
+            <a:spLocks xmlns:a="http://schemas.openxmlformats.org/drawingml/2006/main" noGrp="1"/>
+          </p:cNvSpPr>
+          <p:nvPr/>
+        </p:nvSpPr>
+        <p:spPr>
+          <a:xfrm xmlns:a="http://schemas.openxmlformats.org/drawingml/2006/main">
+            <a:off x="6257925" y="2190750"/>
+            <a:ext cx="5534025" cy="2647950"/>
+          </a:xfrm>
+          <a:prstGeom xmlns:a="http://schemas.openxmlformats.org/drawingml/2006/main" prst="rect">
+            <a:avLst/>
+          </a:prstGeom>
+          <a:solidFill xmlns:a="http://schemas.openxmlformats.org/drawingml/2006/main">
+            <a:srgbClr val="EDEDED"/>
+          </a:solidFill>
+          <a:ln xmlns:a="http://schemas.openxmlformats.org/drawingml/2006/main" w="0">
+            <a:noFill/>
+            <a:prstDash val="solid"/>
+          </a:ln>
+        </p:spPr>
+      </p:sp>
+      <p:sp>
+        <p:nvSpPr>
+          <p:cNvPr id="9" name="after-title">
+            <a:extLst xmlns:a="http://schemas.openxmlformats.org/drawingml/2006/main">
+              <a:ext uri="{FF2B5EF4-FFF2-40B4-BE49-F238E27FC236}">
+                <a16:creationId xmlns:a16="http://schemas.microsoft.com/office/drawing/2014/main" id="{727DE855-58BA-463F-BF61-D642A11514F3}"/>
+              </a:ext>
+            </a:extLst>
+          </p:cNvPr>
+          <p:cNvSpPr>
+            <a:spLocks xmlns:a="http://schemas.openxmlformats.org/drawingml/2006/main" noGrp="1"/>
+          </p:cNvSpPr>
+          <p:nvPr/>
+        </p:nvSpPr>
+        <p:spPr>
+          <a:xfrm xmlns:a="http://schemas.openxmlformats.org/drawingml/2006/main">
+            <a:off x="6562725" y="2457450"/>
+            <a:ext cx="1238250" cy="323850"/>
+          </a:xfrm>
+          <a:prstGeom xmlns:a="http://schemas.openxmlformats.org/drawingml/2006/main" prst="rect">
+            <a:avLst/>
+          </a:prstGeom>
+          <a:noFill xmlns:a="http://schemas.openxmlformats.org/drawingml/2006/main"/>
+          <a:ln xmlns:a="http://schemas.openxmlformats.org/drawingml/2006/main" w="0">
+            <a:noFill/>
+            <a:prstDash val="solid"/>
+          </a:ln>
+        </p:spPr>
+        <p:txBody>
+          <a:bodyPr xmlns:a="http://schemas.openxmlformats.org/drawingml/2006/main" wrap="square" lIns="0" tIns="0" rIns="0" bIns="0" anchor="t">
+            <a:normAutofit fontScale="87449"/>
+          </a:bodyPr>
+          <a:lstStyle xmlns:a="http://schemas.openxmlformats.org/drawingml/2006/main"/>
+          <a:p xmlns:a="http://schemas.openxmlformats.org/drawingml/2006/main">
+            <a:pPr algn="l">
+              <a:lnSpc>
+                <a:spcPct val="108000"/>
+              </a:lnSpc>
+              <a:buNone/>
+              <a:defRPr sz="2250" b="0">
+                <a:solidFill>
+                  <a:srgbClr val="000000"/>
+                </a:solidFill>
+                <a:latin typeface="Helvetica Neue"/>
+                <a:ea typeface="Helvetica Neue"/>
+                <a:cs typeface="Helvetica Neue"/>
+              </a:defRPr>
+            </a:pPr>
+            <a:r>
+              <a:rPr sz="2250" b="0">
+                <a:solidFill>
+                  <a:srgbClr val="000000"/>
+                </a:solidFill>
+                <a:latin typeface="Helvetica Neue"/>
+                <a:ea typeface="Helvetica Neue"/>
+                <a:cs typeface="Helvetica Neue"/>
+              </a:rPr>
+              <a:t>Après</a:t>
+            </a:r>
+          </a:p>
+        </p:txBody>
+      </p:sp>
+      <p:sp>
+        <p:nvSpPr>
+          <p:cNvPr id="10" name="after-bullets">
+            <a:extLst xmlns:a="http://schemas.openxmlformats.org/drawingml/2006/main">
+              <a:ext uri="{FF2B5EF4-FFF2-40B4-BE49-F238E27FC236}">
+                <a16:creationId xmlns:a16="http://schemas.microsoft.com/office/drawing/2014/main" id="{6FA4707D-97D5-46D5-9A30-455F52CDEED3}"/>
+              </a:ext>
+            </a:extLst>
+          </p:cNvPr>
+          <p:cNvSpPr>
+            <a:spLocks xmlns:a="http://schemas.openxmlformats.org/drawingml/2006/main" noGrp="1"/>
+          </p:cNvSpPr>
+          <p:nvPr/>
+        </p:nvSpPr>
+        <p:spPr>
+          <a:xfrm xmlns:a="http://schemas.openxmlformats.org/drawingml/2006/main">
+            <a:off x="6562725" y="2990850"/>
+            <a:ext cx="4857750" cy="1428750"/>
+          </a:xfrm>
+          <a:prstGeom xmlns:a="http://schemas.openxmlformats.org/drawingml/2006/main" prst="rect">
+            <a:avLst/>
+          </a:prstGeom>
+          <a:noFill xmlns:a="http://schemas.openxmlformats.org/drawingml/2006/main"/>
+          <a:ln xmlns:a="http://schemas.openxmlformats.org/drawingml/2006/main" w="0">
+            <a:noFill/>
+            <a:prstDash val="solid"/>
+          </a:ln>
+        </p:spPr>
+        <p:txBody>
+          <a:bodyPr xmlns:a="http://schemas.openxmlformats.org/drawingml/2006/main" wrap="square" lIns="0" tIns="0" rIns="0" bIns="0" anchor="t">
+            <a:normAutofit fontScale="94792"/>
+          </a:bodyPr>
+          <a:lstStyle xmlns:a="http://schemas.openxmlformats.org/drawingml/2006/main"/>
+          <a:p xmlns:a="http://schemas.openxmlformats.org/drawingml/2006/main">
+            <a:pPr marL="24" indent="-14" algn="l">
+              <a:lnSpc>
+                <a:spcPct val="115000"/>
+              </a:lnSpc>
+              <a:buNone/>
+              <a:defRPr sz="1350" b="0">
+                <a:solidFill>
+                  <a:srgbClr val="222222"/>
+                </a:solidFill>
+                <a:latin typeface="Helvetica Neue"/>
+                <a:ea typeface="Helvetica Neue"/>
+                <a:cs typeface="Helvetica Neue"/>
+              </a:defRPr>
+            </a:pPr>
+            <a:r>
+              <a:rPr sz="1350" b="0">
+                <a:solidFill>
+                  <a:srgbClr val="222222"/>
+                </a:solidFill>
+                <a:latin typeface="Helvetica Neue"/>
+                <a:ea typeface="Helvetica Neue"/>
+                <a:cs typeface="Helvetica Neue"/>
+              </a:rPr>
+              <a:t>Moins de temps perdu à reprendre la forme des données déjà disponibles.</a:t>
+            </a:r>
+          </a:p>
+          <a:p xmlns:a="http://schemas.openxmlformats.org/drawingml/2006/main">
+            <a:pPr marL="24" indent="-14" algn="l">
+              <a:lnSpc>
+                <a:spcPct val="115000"/>
+              </a:lnSpc>
+              <a:buNone/>
+              <a:defRPr sz="1350" b="0">
+                <a:solidFill>
+                  <a:srgbClr val="222222"/>
+                </a:solidFill>
+                <a:latin typeface="Helvetica Neue"/>
+                <a:ea typeface="Helvetica Neue"/>
+                <a:cs typeface="Helvetica Neue"/>
+              </a:defRPr>
+            </a:pPr>
+            <a:r>
+              <a:rPr sz="1350" b="0">
+                <a:solidFill>
+                  <a:srgbClr val="222222"/>
+                </a:solidFill>
+                <a:latin typeface="Helvetica Neue"/>
+                <a:ea typeface="Helvetica Neue"/>
+                <a:cs typeface="Helvetica Neue"/>
+              </a:rPr>
+              <a:t>Détection plus précoce des anomalies et des écarts importants.</a:t>
+            </a:r>
+          </a:p>
+          <a:p xmlns:a="http://schemas.openxmlformats.org/drawingml/2006/main">
+            <a:pPr marL="24" indent="-14" algn="l">
+              <a:lnSpc>
+                <a:spcPct val="115000"/>
+              </a:lnSpc>
+              <a:buNone/>
+              <a:defRPr sz="1350" b="0">
+                <a:solidFill>
+                  <a:srgbClr val="222222"/>
+                </a:solidFill>
+                <a:latin typeface="Helvetica Neue"/>
+                <a:ea typeface="Helvetica Neue"/>
+                <a:cs typeface="Helvetica Neue"/>
+              </a:defRPr>
+            </a:pPr>
+            <a:r>
+              <a:rPr sz="1350" b="0">
+                <a:solidFill>
+                  <a:srgbClr val="222222"/>
+                </a:solidFill>
+                <a:latin typeface="Helvetica Neue"/>
+                <a:ea typeface="Helvetica Neue"/>
+                <a:cs typeface="Helvetica Neue"/>
+              </a:rPr>
+              <a:t>Notes de synthèse plus homogènes entre comptabilité, contrôle et audit.</a:t>
+            </a:r>
+          </a:p>
+          <a:p xmlns:a="http://schemas.openxmlformats.org/drawingml/2006/main">
+            <a:pPr marL="24" indent="-14" algn="l">
+              <a:lnSpc>
+                <a:spcPct val="115000"/>
+              </a:lnSpc>
+              <a:buNone/>
+              <a:defRPr sz="1350" b="0">
+                <a:solidFill>
+                  <a:srgbClr val="222222"/>
+                </a:solidFill>
+                <a:latin typeface="Helvetica Neue"/>
+                <a:ea typeface="Helvetica Neue"/>
+                <a:cs typeface="Helvetica Neue"/>
+              </a:defRPr>
+            </a:pPr>
+            <a:r>
+              <a:rPr sz="1350" b="0">
+                <a:solidFill>
+                  <a:srgbClr val="222222"/>
+                </a:solidFill>
+                <a:latin typeface="Helvetica Neue"/>
+                <a:ea typeface="Helvetica Neue"/>
+                <a:cs typeface="Helvetica Neue"/>
+              </a:rPr>
+              <a:t>Meilleure préparation des comités et des arbitrages managériaux.</a:t>
+            </a:r>
+          </a:p>
+        </p:txBody>
+      </p:sp>
+      <p:sp>
+        <p:nvSpPr>
+          <p:cNvPr id="11" name="benefits-footer">
+            <a:extLst xmlns:a="http://schemas.openxmlformats.org/drawingml/2006/main">
+              <a:ext uri="{FF2B5EF4-FFF2-40B4-BE49-F238E27FC236}">
+                <a16:creationId xmlns:a16="http://schemas.microsoft.com/office/drawing/2014/main" id="{ED09CD28-7E34-413E-BC9A-981AC8657017}"/>
+              </a:ext>
+            </a:extLst>
+          </p:cNvPr>
+          <p:cNvSpPr>
+            <a:spLocks xmlns:a="http://schemas.openxmlformats.org/drawingml/2006/main" noGrp="1"/>
+          </p:cNvSpPr>
+          <p:nvPr/>
+        </p:nvSpPr>
+        <p:spPr>
+          <a:xfrm xmlns:a="http://schemas.openxmlformats.org/drawingml/2006/main">
+            <a:off x="400050" y="5334000"/>
+            <a:ext cx="11391900" cy="419100"/>
           </a:xfrm>
           <a:prstGeom xmlns:a="http://schemas.openxmlformats.org/drawingml/2006/main" prst="rect">
             <a:avLst/>
@@ -4759,6 +5480,243 @@
                 <a:spcPct val="108000"/>
               </a:lnSpc>
               <a:buNone/>
+              <a:defRPr sz="1650" b="0">
+                <a:solidFill>
+                  <a:srgbClr val="000000"/>
+                </a:solidFill>
+                <a:latin typeface="Helvetica Neue"/>
+                <a:ea typeface="Helvetica Neue"/>
+                <a:cs typeface="Helvetica Neue"/>
+              </a:defRPr>
+            </a:pPr>
+            <a:r>
+              <a:rPr sz="1650" b="0">
+                <a:solidFill>
+                  <a:srgbClr val="000000"/>
+                </a:solidFill>
+                <a:latin typeface="Helvetica Neue"/>
+                <a:ea typeface="Helvetica Neue"/>
+                <a:cs typeface="Helvetica Neue"/>
+              </a:rPr>
+              <a:t>Contrôle humain maintenu sur tous les usages sensibles et sur toute diffusion officielle.</a:t>
+            </a:r>
+          </a:p>
+        </p:txBody>
+      </p:sp>
+      <p:sp>
+        <p:nvSpPr>
+          <p:cNvPr id="12" name="footer-04">
+            <a:extLst xmlns:a="http://schemas.openxmlformats.org/drawingml/2006/main">
+              <a:ext uri="{FF2B5EF4-FFF2-40B4-BE49-F238E27FC236}">
+                <a16:creationId xmlns:a16="http://schemas.microsoft.com/office/drawing/2014/main" id="{378BD9D6-49EE-4886-A7B8-C78A2843B183}"/>
+              </a:ext>
+            </a:extLst>
+          </p:cNvPr>
+          <p:cNvSpPr>
+            <a:spLocks xmlns:a="http://schemas.openxmlformats.org/drawingml/2006/main" noGrp="1"/>
+          </p:cNvSpPr>
+          <p:nvPr/>
+        </p:nvSpPr>
+        <p:spPr>
+          <a:xfrm xmlns:a="http://schemas.openxmlformats.org/drawingml/2006/main">
+            <a:off x="11220450" y="6276975"/>
+            <a:ext cx="533400" cy="209550"/>
+          </a:xfrm>
+          <a:prstGeom xmlns:a="http://schemas.openxmlformats.org/drawingml/2006/main" prst="rect">
+            <a:avLst/>
+          </a:prstGeom>
+          <a:noFill xmlns:a="http://schemas.openxmlformats.org/drawingml/2006/main"/>
+          <a:ln xmlns:a="http://schemas.openxmlformats.org/drawingml/2006/main" w="0">
+            <a:noFill/>
+            <a:prstDash val="solid"/>
+          </a:ln>
+        </p:spPr>
+        <p:txBody>
+          <a:bodyPr xmlns:a="http://schemas.openxmlformats.org/drawingml/2006/main" wrap="square" lIns="0" tIns="0" rIns="0" bIns="0" anchor="t">
+            <a:noAutofit/>
+          </a:bodyPr>
+          <a:lstStyle xmlns:a="http://schemas.openxmlformats.org/drawingml/2006/main"/>
+          <a:p xmlns:a="http://schemas.openxmlformats.org/drawingml/2006/main">
+            <a:pPr algn="r">
+              <a:lnSpc>
+                <a:spcPct val="108000"/>
+              </a:lnSpc>
+              <a:buNone/>
+              <a:defRPr sz="1050" b="0">
+                <a:solidFill>
+                  <a:srgbClr val="555555"/>
+                </a:solidFill>
+                <a:latin typeface="Helvetica Neue"/>
+                <a:ea typeface="Helvetica Neue"/>
+                <a:cs typeface="Helvetica Neue"/>
+              </a:defRPr>
+            </a:pPr>
+            <a:r>
+              <a:rPr sz="1050" b="0">
+                <a:solidFill>
+                  <a:srgbClr val="555555"/>
+                </a:solidFill>
+                <a:latin typeface="Helvetica Neue"/>
+                <a:ea typeface="Helvetica Neue"/>
+                <a:cs typeface="Helvetica Neue"/>
+              </a:rPr>
+              <a:t>05</a:t>
+            </a:r>
+          </a:p>
+        </p:txBody>
+      </p:sp>
+    </p:spTree>
+    <p:extLst>
+      <p:ext uri="{BB962C8B-B14F-4D97-AF65-F5344CB8AC3E}">
+        <p14:creationId xmlns:p14="http://schemas.microsoft.com/office/powerpoint/2010/main" val="225802777"/>
+      </p:ext>
+    </p:extLst>
+  </p:cSld>
+</p:sld>
+</file>
+
+<file path=ppt/slides/slide6.xml><?xml version="1.0" encoding="utf-8"?>
+<p:sld xmlns:p="http://schemas.openxmlformats.org/presentationml/2006/main">
+  <p:cSld>
+    <p:bg>
+      <p:bgPr>
+        <a:solidFill xmlns:a="http://schemas.openxmlformats.org/drawingml/2006/main">
+          <a:srgbClr val="FFFFFF"/>
+        </a:solidFill>
+      </p:bgPr>
+    </p:bg>
+    <p:spTree>
+      <p:nvGrpSpPr>
+        <p:cNvPr id="1" name=""/>
+        <p:cNvGrpSpPr/>
+        <p:nvPr/>
+      </p:nvGrpSpPr>
+      <p:grpSpPr>
+        <a:xfrm xmlns:a="http://schemas.openxmlformats.org/drawingml/2006/main"/>
+      </p:grpSpPr>
+      <p:sp>
+        <p:nvSpPr>
+          <p:cNvPr id="1" name="section-Pilotage">
+            <a:extLst xmlns:a="http://schemas.openxmlformats.org/drawingml/2006/main">
+              <a:ext uri="{FF2B5EF4-FFF2-40B4-BE49-F238E27FC236}">
+                <a16:creationId xmlns:a16="http://schemas.microsoft.com/office/drawing/2014/main" id="{5AC7B388-201F-4CD8-BC20-D93B6E28C49C}"/>
+              </a:ext>
+            </a:extLst>
+          </p:cNvPr>
+          <p:cNvSpPr>
+            <a:spLocks xmlns:a="http://schemas.openxmlformats.org/drawingml/2006/main" noGrp="1"/>
+          </p:cNvSpPr>
+          <p:nvPr/>
+        </p:nvSpPr>
+        <p:spPr>
+          <a:xfrm xmlns:a="http://schemas.openxmlformats.org/drawingml/2006/main">
+            <a:off x="400050" y="76200"/>
+            <a:ext cx="2095500" cy="190500"/>
+          </a:xfrm>
+          <a:prstGeom xmlns:a="http://schemas.openxmlformats.org/drawingml/2006/main" prst="rect">
+            <a:avLst/>
+          </a:prstGeom>
+          <a:noFill xmlns:a="http://schemas.openxmlformats.org/drawingml/2006/main"/>
+          <a:ln xmlns:a="http://schemas.openxmlformats.org/drawingml/2006/main" w="0">
+            <a:noFill/>
+            <a:prstDash val="solid"/>
+          </a:ln>
+        </p:spPr>
+        <p:txBody>
+          <a:bodyPr xmlns:a="http://schemas.openxmlformats.org/drawingml/2006/main" wrap="square" lIns="0" tIns="0" rIns="0" bIns="0" anchor="t">
+            <a:noAutofit/>
+          </a:bodyPr>
+          <a:lstStyle xmlns:a="http://schemas.openxmlformats.org/drawingml/2006/main"/>
+          <a:p xmlns:a="http://schemas.openxmlformats.org/drawingml/2006/main">
+            <a:pPr algn="l">
+              <a:lnSpc>
+                <a:spcPct val="108000"/>
+              </a:lnSpc>
+              <a:buNone/>
+              <a:defRPr sz="900" b="1">
+                <a:solidFill>
+                  <a:srgbClr val="555555"/>
+                </a:solidFill>
+                <a:latin typeface="Helvetica Neue"/>
+                <a:ea typeface="Helvetica Neue"/>
+                <a:cs typeface="Helvetica Neue"/>
+              </a:defRPr>
+            </a:pPr>
+            <a:r>
+              <a:rPr sz="900" b="1">
+                <a:solidFill>
+                  <a:srgbClr val="555555"/>
+                </a:solidFill>
+                <a:latin typeface="Helvetica Neue"/>
+                <a:ea typeface="Helvetica Neue"/>
+                <a:cs typeface="Helvetica Neue"/>
+              </a:rPr>
+              <a:t>Pilotage</a:t>
+            </a:r>
+          </a:p>
+        </p:txBody>
+      </p:sp>
+      <p:pic>
+        <p:nvPicPr>
+          <p:cNvPr id="27" name=""/>
+          <p:cNvPicPr>
+            <a:picLocks xmlns:a="http://schemas.openxmlformats.org/drawingml/2006/main" noChangeAspect="1"/>
+          </p:cNvPicPr>
+          <p:nvPr/>
+        </p:nvPicPr>
+        <p:blipFill>
+          <a:blip xmlns:r="http://schemas.openxmlformats.org/officeDocument/2006/relationships" xmlns:a="http://schemas.openxmlformats.org/drawingml/2006/main" r:embed="R770ca22b10864d10"/>
+          <a:stretch xmlns:a="http://schemas.openxmlformats.org/drawingml/2006/main"/>
+        </p:blipFill>
+        <p:spPr>
+          <a:xfrm xmlns:a="http://schemas.openxmlformats.org/drawingml/2006/main">
+            <a:off x="10049653" y="152400"/>
+            <a:ext cx="1046195" cy="495300"/>
+          </a:xfrm>
+          <a:prstGeom xmlns:a="http://schemas.openxmlformats.org/drawingml/2006/main" prst="rect">
+            <a:avLst/>
+          </a:prstGeom>
+        </p:spPr>
+      </p:pic>
+      <p:sp>
+        <p:nvSpPr>
+          <p:cNvPr id="3" name="kpi-title">
+            <a:extLst xmlns:a="http://schemas.openxmlformats.org/drawingml/2006/main">
+              <a:ext uri="{FF2B5EF4-FFF2-40B4-BE49-F238E27FC236}">
+                <a16:creationId xmlns:a16="http://schemas.microsoft.com/office/drawing/2014/main" id="{9A7C8067-8DEF-44DC-A61A-ECE74F2A5D95}"/>
+              </a:ext>
+            </a:extLst>
+          </p:cNvPr>
+          <p:cNvSpPr>
+            <a:spLocks xmlns:a="http://schemas.openxmlformats.org/drawingml/2006/main" noGrp="1"/>
+          </p:cNvSpPr>
+          <p:nvPr/>
+        </p:nvSpPr>
+        <p:spPr>
+          <a:xfrm xmlns:a="http://schemas.openxmlformats.org/drawingml/2006/main">
+            <a:off x="400050" y="342900"/>
+            <a:ext cx="10668000" cy="552450"/>
+          </a:xfrm>
+          <a:prstGeom xmlns:a="http://schemas.openxmlformats.org/drawingml/2006/main" prst="rect">
+            <a:avLst/>
+          </a:prstGeom>
+          <a:noFill xmlns:a="http://schemas.openxmlformats.org/drawingml/2006/main"/>
+          <a:ln xmlns:a="http://schemas.openxmlformats.org/drawingml/2006/main" w="0">
+            <a:noFill/>
+            <a:prstDash val="solid"/>
+          </a:ln>
+        </p:spPr>
+        <p:txBody>
+          <a:bodyPr xmlns:a="http://schemas.openxmlformats.org/drawingml/2006/main" wrap="square" lIns="0" tIns="0" rIns="0" bIns="0" anchor="t">
+            <a:normAutofit fontScale="100000"/>
+          </a:bodyPr>
+          <a:lstStyle xmlns:a="http://schemas.openxmlformats.org/drawingml/2006/main"/>
+          <a:p xmlns:a="http://schemas.openxmlformats.org/drawingml/2006/main">
+            <a:pPr algn="l">
+              <a:lnSpc>
+                <a:spcPct val="108000"/>
+              </a:lnSpc>
+              <a:buNone/>
               <a:defRPr sz="2775" b="0">
                 <a:solidFill>
                   <a:srgbClr val="000000"/>
@@ -5924,7 +6882,7 @@
                 <a:ea typeface="Helvetica Neue"/>
                 <a:cs typeface="Helvetica Neue"/>
               </a:rPr>
-              <a:t>05</a:t>
+              <a:t>06</a:t>
             </a:r>
           </a:p>
         </p:txBody>

</xml_diff>